<commit_message>
#PIP-135 Add the Warsaw live-demo menu and Riccardo's updated decks
Checkpoint of the material as it arrived: the live-demo main menu notebook
and the two presentation decks, committed unchanged.

The menu's links still point at the folder layout of Riccardo's repository
(8_ipscore_rebuild_v2/, 6_patentreports/) and resolve to nothing here. They
are corrected in a follow-up commit, once his module is imported, so that
this state stays recoverable.

Co-Authored-By: Claude Opus 5 (1M context) <noreply@anthropic.com>
Claude-Session: https://claude.ai/code/session_0171ichqecyZpSqpkZr66qAU
</commit_message>
<xml_diff>
--- a/9_documentation/course/TIP4PATLIBS_AntibioticResistance_LiveDemo_Warsaw2026.pptx
+++ b/9_documentation/course/TIP4PATLIBS_AntibioticResistance_LiveDemo_Warsaw2026.pptx
@@ -5,19 +5,19 @@
     <p:sldMasterId id="2147483648" r:id="rId1"/>
   </p:sldMasterIdLst>
   <p:sldIdLst>
-    <p:sldId id="256" r:id="rId2"/>
-    <p:sldId id="257" r:id="rId3"/>
-    <p:sldId id="258" r:id="rId4"/>
-    <p:sldId id="259" r:id="rId5"/>
-    <p:sldId id="260" r:id="rId6"/>
-    <p:sldId id="261" r:id="rId7"/>
-    <p:sldId id="262" r:id="rId8"/>
-    <p:sldId id="263" r:id="rId9"/>
-    <p:sldId id="264" r:id="rId10"/>
-    <p:sldId id="265" r:id="rId11"/>
-    <p:sldId id="266" r:id="rId12"/>
+    <p:sldId id="256" r:id="rId7"/>
+    <p:sldId id="257" r:id="rId8"/>
+    <p:sldId id="258" r:id="rId9"/>
+    <p:sldId id="259" r:id="rId10"/>
+    <p:sldId id="260" r:id="rId11"/>
+    <p:sldId id="261" r:id="rId12"/>
+    <p:sldId id="262" r:id="rId13"/>
+    <p:sldId id="263" r:id="rId14"/>
+    <p:sldId id="264" r:id="rId15"/>
+    <p:sldId id="265" r:id="rId16"/>
+    <p:sldId id="266" r:id="rId17"/>
   </p:sldIdLst>
-  <p:sldSz cx="12192000" cy="6858000"/>
+  <p:sldSz cx="12191695" cy="6858000" type="screen4x3"/>
   <p:notesSz cx="6858000" cy="9144000"/>
   <p:defaultTextStyle>
     <a:defPPr>
@@ -114,22 +114,6 @@
       </a:defRPr>
     </a:lvl9pPr>
   </p:defaultTextStyle>
-  <p:extLst>
-    <p:ext uri="{EFAFB233-063F-42B5-8137-9DF3F51BA10A}">
-      <p15:sldGuideLst xmlns:p15="http://schemas.microsoft.com/office/powerpoint/2012/main">
-        <p15:guide id="1" orient="horz" pos="2160">
-          <p15:clr>
-            <a:srgbClr val="A4A3A4"/>
-          </p15:clr>
-        </p15:guide>
-        <p15:guide id="2" pos="2880">
-          <p15:clr>
-            <a:srgbClr val="A4A3A4"/>
-          </p15:clr>
-        </p15:guide>
-      </p15:sldGuideLst>
-    </p:ext>
-  </p:extLst>
 </p:presentation>
 </file>
 
@@ -171,9 +155,10 @@
           <a:lstStyle/>
           <a:p>
             <a:r>
-              <a:rPr lang="en-US"/>
+              <a:rPr lang="en-US" smtClean="0"/>
               <a:t>Click to edit Master title style</a:t>
             </a:r>
+            <a:endParaRPr lang="en-US"/>
           </a:p>
         </p:txBody>
       </p:sp>
@@ -289,9 +274,10 @@
           </a:lstStyle>
           <a:p>
             <a:r>
-              <a:rPr lang="en-US"/>
+              <a:rPr lang="en-US" smtClean="0"/>
               <a:t>Click to edit Master subtitle style</a:t>
             </a:r>
+            <a:endParaRPr lang="en-US"/>
           </a:p>
         </p:txBody>
       </p:sp>
@@ -312,7 +298,7 @@
           <a:p>
             <a:fld id="{5BCAD085-E8A6-8845-BD4E-CB4CCA059FC4}" type="datetimeFigureOut">
               <a:rPr lang="en-US" smtClean="0"/>
-              <a:t>8/26/26</a:t>
+              <a:t>1/27/13</a:t>
             </a:fld>
             <a:endParaRPr lang="en-US"/>
           </a:p>
@@ -406,9 +392,10 @@
           <a:lstStyle/>
           <a:p>
             <a:r>
-              <a:rPr lang="en-US"/>
+              <a:rPr lang="en-US" smtClean="0"/>
               <a:t>Click to edit Master title style</a:t>
             </a:r>
+            <a:endParaRPr lang="en-US"/>
           </a:p>
         </p:txBody>
       </p:sp>
@@ -429,37 +416,38 @@
           <a:p>
             <a:pPr lvl="0"/>
             <a:r>
-              <a:rPr lang="en-US"/>
+              <a:rPr lang="en-US" smtClean="0"/>
               <a:t>Click to edit Master text styles</a:t>
             </a:r>
           </a:p>
           <a:p>
             <a:pPr lvl="1"/>
             <a:r>
-              <a:rPr lang="en-US"/>
+              <a:rPr lang="en-US" smtClean="0"/>
               <a:t>Second level</a:t>
             </a:r>
           </a:p>
           <a:p>
             <a:pPr lvl="2"/>
             <a:r>
-              <a:rPr lang="en-US"/>
+              <a:rPr lang="en-US" smtClean="0"/>
               <a:t>Third level</a:t>
             </a:r>
           </a:p>
           <a:p>
             <a:pPr lvl="3"/>
             <a:r>
-              <a:rPr lang="en-US"/>
+              <a:rPr lang="en-US" smtClean="0"/>
               <a:t>Fourth level</a:t>
             </a:r>
           </a:p>
           <a:p>
             <a:pPr lvl="4"/>
             <a:r>
-              <a:rPr lang="en-US"/>
+              <a:rPr lang="en-US" smtClean="0"/>
               <a:t>Fifth level</a:t>
             </a:r>
+            <a:endParaRPr lang="en-US"/>
           </a:p>
         </p:txBody>
       </p:sp>
@@ -480,7 +468,7 @@
           <a:p>
             <a:fld id="{5BCAD085-E8A6-8845-BD4E-CB4CCA059FC4}" type="datetimeFigureOut">
               <a:rPr lang="en-US" smtClean="0"/>
-              <a:t>8/26/26</a:t>
+              <a:t>1/27/13</a:t>
             </a:fld>
             <a:endParaRPr lang="en-US"/>
           </a:p>
@@ -579,9 +567,10 @@
           <a:lstStyle/>
           <a:p>
             <a:r>
-              <a:rPr lang="en-US"/>
+              <a:rPr lang="en-US" smtClean="0"/>
               <a:t>Click to edit Master title style</a:t>
             </a:r>
+            <a:endParaRPr lang="en-US"/>
           </a:p>
         </p:txBody>
       </p:sp>
@@ -607,37 +596,38 @@
           <a:p>
             <a:pPr lvl="0"/>
             <a:r>
-              <a:rPr lang="en-US"/>
+              <a:rPr lang="en-US" smtClean="0"/>
               <a:t>Click to edit Master text styles</a:t>
             </a:r>
           </a:p>
           <a:p>
             <a:pPr lvl="1"/>
             <a:r>
-              <a:rPr lang="en-US"/>
+              <a:rPr lang="en-US" smtClean="0"/>
               <a:t>Second level</a:t>
             </a:r>
           </a:p>
           <a:p>
             <a:pPr lvl="2"/>
             <a:r>
-              <a:rPr lang="en-US"/>
+              <a:rPr lang="en-US" smtClean="0"/>
               <a:t>Third level</a:t>
             </a:r>
           </a:p>
           <a:p>
             <a:pPr lvl="3"/>
             <a:r>
-              <a:rPr lang="en-US"/>
+              <a:rPr lang="en-US" smtClean="0"/>
               <a:t>Fourth level</a:t>
             </a:r>
           </a:p>
           <a:p>
             <a:pPr lvl="4"/>
             <a:r>
-              <a:rPr lang="en-US"/>
+              <a:rPr lang="en-US" smtClean="0"/>
               <a:t>Fifth level</a:t>
             </a:r>
+            <a:endParaRPr lang="en-US"/>
           </a:p>
         </p:txBody>
       </p:sp>
@@ -658,7 +648,7 @@
           <a:p>
             <a:fld id="{5BCAD085-E8A6-8845-BD4E-CB4CCA059FC4}" type="datetimeFigureOut">
               <a:rPr lang="en-US" smtClean="0"/>
-              <a:t>8/26/26</a:t>
+              <a:t>1/27/13</a:t>
             </a:fld>
             <a:endParaRPr lang="en-US"/>
           </a:p>
@@ -752,9 +742,10 @@
           <a:lstStyle/>
           <a:p>
             <a:r>
-              <a:rPr lang="en-US"/>
+              <a:rPr lang="en-US" smtClean="0"/>
               <a:t>Click to edit Master title style</a:t>
             </a:r>
+            <a:endParaRPr lang="en-US"/>
           </a:p>
         </p:txBody>
       </p:sp>
@@ -775,37 +766,38 @@
           <a:p>
             <a:pPr lvl="0"/>
             <a:r>
-              <a:rPr lang="en-US"/>
+              <a:rPr lang="en-US" smtClean="0"/>
               <a:t>Click to edit Master text styles</a:t>
             </a:r>
           </a:p>
           <a:p>
             <a:pPr lvl="1"/>
             <a:r>
-              <a:rPr lang="en-US"/>
+              <a:rPr lang="en-US" smtClean="0"/>
               <a:t>Second level</a:t>
             </a:r>
           </a:p>
           <a:p>
             <a:pPr lvl="2"/>
             <a:r>
-              <a:rPr lang="en-US"/>
+              <a:rPr lang="en-US" smtClean="0"/>
               <a:t>Third level</a:t>
             </a:r>
           </a:p>
           <a:p>
             <a:pPr lvl="3"/>
             <a:r>
-              <a:rPr lang="en-US"/>
+              <a:rPr lang="en-US" smtClean="0"/>
               <a:t>Fourth level</a:t>
             </a:r>
           </a:p>
           <a:p>
             <a:pPr lvl="4"/>
             <a:r>
-              <a:rPr lang="en-US"/>
+              <a:rPr lang="en-US" smtClean="0"/>
               <a:t>Fifth level</a:t>
             </a:r>
+            <a:endParaRPr lang="en-US"/>
           </a:p>
         </p:txBody>
       </p:sp>
@@ -826,7 +818,7 @@
           <a:p>
             <a:fld id="{5BCAD085-E8A6-8845-BD4E-CB4CCA059FC4}" type="datetimeFigureOut">
               <a:rPr lang="en-US" smtClean="0"/>
-              <a:t>8/26/26</a:t>
+              <a:t>1/27/13</a:t>
             </a:fld>
             <a:endParaRPr lang="en-US"/>
           </a:p>
@@ -929,9 +921,10 @@
           </a:lstStyle>
           <a:p>
             <a:r>
-              <a:rPr lang="en-US"/>
+              <a:rPr lang="en-US" smtClean="0"/>
               <a:t>Click to edit Master title style</a:t>
             </a:r>
+            <a:endParaRPr lang="en-US"/>
           </a:p>
         </p:txBody>
       </p:sp>
@@ -1048,7 +1041,7 @@
           <a:p>
             <a:pPr lvl="0"/>
             <a:r>
-              <a:rPr lang="en-US"/>
+              <a:rPr lang="en-US" smtClean="0"/>
               <a:t>Click to edit Master text styles</a:t>
             </a:r>
           </a:p>
@@ -1071,7 +1064,7 @@
           <a:p>
             <a:fld id="{5BCAD085-E8A6-8845-BD4E-CB4CCA059FC4}" type="datetimeFigureOut">
               <a:rPr lang="en-US" smtClean="0"/>
-              <a:t>8/26/26</a:t>
+              <a:t>1/27/13</a:t>
             </a:fld>
             <a:endParaRPr lang="en-US"/>
           </a:p>
@@ -1165,9 +1158,10 @@
           <a:lstStyle/>
           <a:p>
             <a:r>
-              <a:rPr lang="en-US"/>
+              <a:rPr lang="en-US" smtClean="0"/>
               <a:t>Click to edit Master title style</a:t>
             </a:r>
+            <a:endParaRPr lang="en-US"/>
           </a:p>
         </p:txBody>
       </p:sp>
@@ -1221,37 +1215,38 @@
           <a:p>
             <a:pPr lvl="0"/>
             <a:r>
-              <a:rPr lang="en-US"/>
+              <a:rPr lang="en-US" smtClean="0"/>
               <a:t>Click to edit Master text styles</a:t>
             </a:r>
           </a:p>
           <a:p>
             <a:pPr lvl="1"/>
             <a:r>
-              <a:rPr lang="en-US"/>
+              <a:rPr lang="en-US" smtClean="0"/>
               <a:t>Second level</a:t>
             </a:r>
           </a:p>
           <a:p>
             <a:pPr lvl="2"/>
             <a:r>
-              <a:rPr lang="en-US"/>
+              <a:rPr lang="en-US" smtClean="0"/>
               <a:t>Third level</a:t>
             </a:r>
           </a:p>
           <a:p>
             <a:pPr lvl="3"/>
             <a:r>
-              <a:rPr lang="en-US"/>
+              <a:rPr lang="en-US" smtClean="0"/>
               <a:t>Fourth level</a:t>
             </a:r>
           </a:p>
           <a:p>
             <a:pPr lvl="4"/>
             <a:r>
-              <a:rPr lang="en-US"/>
+              <a:rPr lang="en-US" smtClean="0"/>
               <a:t>Fifth level</a:t>
             </a:r>
+            <a:endParaRPr lang="en-US"/>
           </a:p>
         </p:txBody>
       </p:sp>
@@ -1305,37 +1300,38 @@
           <a:p>
             <a:pPr lvl="0"/>
             <a:r>
-              <a:rPr lang="en-US"/>
+              <a:rPr lang="en-US" smtClean="0"/>
               <a:t>Click to edit Master text styles</a:t>
             </a:r>
           </a:p>
           <a:p>
             <a:pPr lvl="1"/>
             <a:r>
-              <a:rPr lang="en-US"/>
+              <a:rPr lang="en-US" smtClean="0"/>
               <a:t>Second level</a:t>
             </a:r>
           </a:p>
           <a:p>
             <a:pPr lvl="2"/>
             <a:r>
-              <a:rPr lang="en-US"/>
+              <a:rPr lang="en-US" smtClean="0"/>
               <a:t>Third level</a:t>
             </a:r>
           </a:p>
           <a:p>
             <a:pPr lvl="3"/>
             <a:r>
-              <a:rPr lang="en-US"/>
+              <a:rPr lang="en-US" smtClean="0"/>
               <a:t>Fourth level</a:t>
             </a:r>
           </a:p>
           <a:p>
             <a:pPr lvl="4"/>
             <a:r>
-              <a:rPr lang="en-US"/>
+              <a:rPr lang="en-US" smtClean="0"/>
               <a:t>Fifth level</a:t>
             </a:r>
+            <a:endParaRPr lang="en-US"/>
           </a:p>
         </p:txBody>
       </p:sp>
@@ -1356,7 +1352,7 @@
           <a:p>
             <a:fld id="{5BCAD085-E8A6-8845-BD4E-CB4CCA059FC4}" type="datetimeFigureOut">
               <a:rPr lang="en-US" smtClean="0"/>
-              <a:t>8/26/26</a:t>
+              <a:t>1/27/13</a:t>
             </a:fld>
             <a:endParaRPr lang="en-US"/>
           </a:p>
@@ -1454,9 +1450,10 @@
           </a:lstStyle>
           <a:p>
             <a:r>
-              <a:rPr lang="en-US"/>
+              <a:rPr lang="en-US" smtClean="0"/>
               <a:t>Click to edit Master title style</a:t>
             </a:r>
+            <a:endParaRPr lang="en-US"/>
           </a:p>
         </p:txBody>
       </p:sp>
@@ -1519,7 +1516,7 @@
           <a:p>
             <a:pPr lvl="0"/>
             <a:r>
-              <a:rPr lang="en-US"/>
+              <a:rPr lang="en-US" smtClean="0"/>
               <a:t>Click to edit Master text styles</a:t>
             </a:r>
           </a:p>
@@ -1575,37 +1572,38 @@
           <a:p>
             <a:pPr lvl="0"/>
             <a:r>
-              <a:rPr lang="en-US"/>
+              <a:rPr lang="en-US" smtClean="0"/>
               <a:t>Click to edit Master text styles</a:t>
             </a:r>
           </a:p>
           <a:p>
             <a:pPr lvl="1"/>
             <a:r>
-              <a:rPr lang="en-US"/>
+              <a:rPr lang="en-US" smtClean="0"/>
               <a:t>Second level</a:t>
             </a:r>
           </a:p>
           <a:p>
             <a:pPr lvl="2"/>
             <a:r>
-              <a:rPr lang="en-US"/>
+              <a:rPr lang="en-US" smtClean="0"/>
               <a:t>Third level</a:t>
             </a:r>
           </a:p>
           <a:p>
             <a:pPr lvl="3"/>
             <a:r>
-              <a:rPr lang="en-US"/>
+              <a:rPr lang="en-US" smtClean="0"/>
               <a:t>Fourth level</a:t>
             </a:r>
           </a:p>
           <a:p>
             <a:pPr lvl="4"/>
             <a:r>
-              <a:rPr lang="en-US"/>
+              <a:rPr lang="en-US" smtClean="0"/>
               <a:t>Fifth level</a:t>
             </a:r>
+            <a:endParaRPr lang="en-US"/>
           </a:p>
         </p:txBody>
       </p:sp>
@@ -1668,7 +1666,7 @@
           <a:p>
             <a:pPr lvl="0"/>
             <a:r>
-              <a:rPr lang="en-US"/>
+              <a:rPr lang="en-US" smtClean="0"/>
               <a:t>Click to edit Master text styles</a:t>
             </a:r>
           </a:p>
@@ -1724,37 +1722,38 @@
           <a:p>
             <a:pPr lvl="0"/>
             <a:r>
-              <a:rPr lang="en-US"/>
+              <a:rPr lang="en-US" smtClean="0"/>
               <a:t>Click to edit Master text styles</a:t>
             </a:r>
           </a:p>
           <a:p>
             <a:pPr lvl="1"/>
             <a:r>
-              <a:rPr lang="en-US"/>
+              <a:rPr lang="en-US" smtClean="0"/>
               <a:t>Second level</a:t>
             </a:r>
           </a:p>
           <a:p>
             <a:pPr lvl="2"/>
             <a:r>
-              <a:rPr lang="en-US"/>
+              <a:rPr lang="en-US" smtClean="0"/>
               <a:t>Third level</a:t>
             </a:r>
           </a:p>
           <a:p>
             <a:pPr lvl="3"/>
             <a:r>
-              <a:rPr lang="en-US"/>
+              <a:rPr lang="en-US" smtClean="0"/>
               <a:t>Fourth level</a:t>
             </a:r>
           </a:p>
           <a:p>
             <a:pPr lvl="4"/>
             <a:r>
-              <a:rPr lang="en-US"/>
+              <a:rPr lang="en-US" smtClean="0"/>
               <a:t>Fifth level</a:t>
             </a:r>
+            <a:endParaRPr lang="en-US"/>
           </a:p>
         </p:txBody>
       </p:sp>
@@ -1775,7 +1774,7 @@
           <a:p>
             <a:fld id="{5BCAD085-E8A6-8845-BD4E-CB4CCA059FC4}" type="datetimeFigureOut">
               <a:rPr lang="en-US" smtClean="0"/>
-              <a:t>8/26/26</a:t>
+              <a:t>1/27/13</a:t>
             </a:fld>
             <a:endParaRPr lang="en-US"/>
           </a:p>
@@ -1869,9 +1868,10 @@
           <a:lstStyle/>
           <a:p>
             <a:r>
-              <a:rPr lang="en-US"/>
+              <a:rPr lang="en-US" smtClean="0"/>
               <a:t>Click to edit Master title style</a:t>
             </a:r>
+            <a:endParaRPr lang="en-US"/>
           </a:p>
         </p:txBody>
       </p:sp>
@@ -1892,7 +1892,7 @@
           <a:p>
             <a:fld id="{5BCAD085-E8A6-8845-BD4E-CB4CCA059FC4}" type="datetimeFigureOut">
               <a:rPr lang="en-US" smtClean="0"/>
-              <a:t>8/26/26</a:t>
+              <a:t>1/27/13</a:t>
             </a:fld>
             <a:endParaRPr lang="en-US"/>
           </a:p>
@@ -1987,7 +1987,7 @@
           <a:p>
             <a:fld id="{5BCAD085-E8A6-8845-BD4E-CB4CCA059FC4}" type="datetimeFigureOut">
               <a:rPr lang="en-US" smtClean="0"/>
-              <a:t>8/26/26</a:t>
+              <a:t>1/27/13</a:t>
             </a:fld>
             <a:endParaRPr lang="en-US"/>
           </a:p>
@@ -2090,9 +2090,10 @@
           </a:lstStyle>
           <a:p>
             <a:r>
-              <a:rPr lang="en-US"/>
+              <a:rPr lang="en-US" smtClean="0"/>
               <a:t>Click to edit Master title style</a:t>
             </a:r>
+            <a:endParaRPr lang="en-US"/>
           </a:p>
         </p:txBody>
       </p:sp>
@@ -2146,37 +2147,38 @@
           <a:p>
             <a:pPr lvl="0"/>
             <a:r>
-              <a:rPr lang="en-US"/>
+              <a:rPr lang="en-US" smtClean="0"/>
               <a:t>Click to edit Master text styles</a:t>
             </a:r>
           </a:p>
           <a:p>
             <a:pPr lvl="1"/>
             <a:r>
-              <a:rPr lang="en-US"/>
+              <a:rPr lang="en-US" smtClean="0"/>
               <a:t>Second level</a:t>
             </a:r>
           </a:p>
           <a:p>
             <a:pPr lvl="2"/>
             <a:r>
-              <a:rPr lang="en-US"/>
+              <a:rPr lang="en-US" smtClean="0"/>
               <a:t>Third level</a:t>
             </a:r>
           </a:p>
           <a:p>
             <a:pPr lvl="3"/>
             <a:r>
-              <a:rPr lang="en-US"/>
+              <a:rPr lang="en-US" smtClean="0"/>
               <a:t>Fourth level</a:t>
             </a:r>
           </a:p>
           <a:p>
             <a:pPr lvl="4"/>
             <a:r>
-              <a:rPr lang="en-US"/>
+              <a:rPr lang="en-US" smtClean="0"/>
               <a:t>Fifth level</a:t>
             </a:r>
+            <a:endParaRPr lang="en-US"/>
           </a:p>
         </p:txBody>
       </p:sp>
@@ -2239,7 +2241,7 @@
           <a:p>
             <a:pPr lvl="0"/>
             <a:r>
-              <a:rPr lang="en-US"/>
+              <a:rPr lang="en-US" smtClean="0"/>
               <a:t>Click to edit Master text styles</a:t>
             </a:r>
           </a:p>
@@ -2262,7 +2264,7 @@
           <a:p>
             <a:fld id="{5BCAD085-E8A6-8845-BD4E-CB4CCA059FC4}" type="datetimeFigureOut">
               <a:rPr lang="en-US" smtClean="0"/>
-              <a:t>8/26/26</a:t>
+              <a:t>1/27/13</a:t>
             </a:fld>
             <a:endParaRPr lang="en-US"/>
           </a:p>
@@ -2365,9 +2367,10 @@
           </a:lstStyle>
           <a:p>
             <a:r>
-              <a:rPr lang="en-US"/>
+              <a:rPr lang="en-US" smtClean="0"/>
               <a:t>Click to edit Master title style</a:t>
             </a:r>
+            <a:endParaRPr lang="en-US"/>
           </a:p>
         </p:txBody>
       </p:sp>
@@ -2491,7 +2494,7 @@
           <a:p>
             <a:pPr lvl="0"/>
             <a:r>
-              <a:rPr lang="en-US"/>
+              <a:rPr lang="en-US" smtClean="0"/>
               <a:t>Click to edit Master text styles</a:t>
             </a:r>
           </a:p>
@@ -2514,7 +2517,7 @@
           <a:p>
             <a:fld id="{5BCAD085-E8A6-8845-BD4E-CB4CCA059FC4}" type="datetimeFigureOut">
               <a:rPr lang="en-US" smtClean="0"/>
-              <a:t>8/26/26</a:t>
+              <a:t>1/27/13</a:t>
             </a:fld>
             <a:endParaRPr lang="en-US"/>
           </a:p>
@@ -2623,9 +2626,10 @@
           <a:lstStyle/>
           <a:p>
             <a:r>
-              <a:rPr lang="en-US"/>
+              <a:rPr lang="en-US" smtClean="0"/>
               <a:t>Click to edit Master title style</a:t>
             </a:r>
+            <a:endParaRPr lang="en-US"/>
           </a:p>
         </p:txBody>
       </p:sp>
@@ -2656,37 +2660,38 @@
           <a:p>
             <a:pPr lvl="0"/>
             <a:r>
-              <a:rPr lang="en-US"/>
+              <a:rPr lang="en-US" smtClean="0"/>
               <a:t>Click to edit Master text styles</a:t>
             </a:r>
           </a:p>
           <a:p>
             <a:pPr lvl="1"/>
             <a:r>
-              <a:rPr lang="en-US"/>
+              <a:rPr lang="en-US" smtClean="0"/>
               <a:t>Second level</a:t>
             </a:r>
           </a:p>
           <a:p>
             <a:pPr lvl="2"/>
             <a:r>
-              <a:rPr lang="en-US"/>
+              <a:rPr lang="en-US" smtClean="0"/>
               <a:t>Third level</a:t>
             </a:r>
           </a:p>
           <a:p>
             <a:pPr lvl="3"/>
             <a:r>
-              <a:rPr lang="en-US"/>
+              <a:rPr lang="en-US" smtClean="0"/>
               <a:t>Fourth level</a:t>
             </a:r>
           </a:p>
           <a:p>
             <a:pPr lvl="4"/>
             <a:r>
-              <a:rPr lang="en-US"/>
+              <a:rPr lang="en-US" smtClean="0"/>
               <a:t>Fifth level</a:t>
             </a:r>
+            <a:endParaRPr lang="en-US"/>
           </a:p>
         </p:txBody>
       </p:sp>
@@ -2725,7 +2730,7 @@
           <a:p>
             <a:fld id="{5BCAD085-E8A6-8845-BD4E-CB4CCA059FC4}" type="datetimeFigureOut">
               <a:rPr lang="en-US" smtClean="0"/>
-              <a:t>8/26/26</a:t>
+              <a:t>1/27/13</a:t>
             </a:fld>
             <a:endParaRPr lang="en-US"/>
           </a:p>
@@ -3084,7 +3089,7 @@
 </file>
 
 <file path=ppt/slides/slide1.xml><?xml version="1.0" encoding="utf-8"?>
-<p:sld xmlns:a="http://schemas.openxmlformats.org/drawingml/2006/main" xmlns:r="http://schemas.openxmlformats.org/officeDocument/2006/relationships" xmlns:p="http://schemas.openxmlformats.org/presentationml/2006/main">
+<p:sld xmlns:a="http://schemas.openxmlformats.org/drawingml/2006/main" xmlns:p="http://schemas.openxmlformats.org/presentationml/2006/main" xmlns:r="http://schemas.openxmlformats.org/officeDocument/2006/relationships">
   <p:cSld>
     <p:spTree>
       <p:nvGrpSpPr>
@@ -3092,14 +3097,7 @@
         <p:cNvGrpSpPr/>
         <p:nvPr/>
       </p:nvGrpSpPr>
-      <p:grpSpPr>
-        <a:xfrm>
-          <a:off x="0" y="0"/>
-          <a:ext cx="0" cy="0"/>
-          <a:chOff x="0" y="0"/>
-          <a:chExt cx="0" cy="0"/>
-        </a:xfrm>
-      </p:grpSpPr>
+      <p:grpSpPr/>
       <p:sp>
         <p:nvSpPr>
           <p:cNvPr id="2" name="Rectangle 1"/>
@@ -3137,11 +3135,10 @@
           </a:fontRef>
         </p:style>
         <p:txBody>
-          <a:bodyPr wrap="square" rtlCol="0" anchor="ctr"/>
+          <a:bodyPr rtlCol="0" anchor="ctr" wrap="square"/>
           <a:lstStyle/>
           <a:p>
             <a:pPr algn="ctr"/>
-            <a:endParaRPr/>
           </a:p>
         </p:txBody>
       </p:sp>
@@ -3162,7 +3159,7 @@
           <a:noFill/>
         </p:spPr>
         <p:txBody>
-          <a:bodyPr wrap="square" lIns="0" tIns="0" rIns="0" bIns="0" anchor="t">
+          <a:bodyPr wrap="square" anchor="t" lIns="0" rIns="0" tIns="0" bIns="0">
             <a:spAutoFit/>
           </a:bodyPr>
           <a:lstStyle/>
@@ -3264,7 +3261,7 @@
           </a:fontRef>
         </p:style>
         <p:txBody>
-          <a:bodyPr wrap="square" lIns="274320" tIns="146304" rIns="274320" bIns="146304" rtlCol="0" anchor="ctr"/>
+          <a:bodyPr rtlCol="0" anchor="ctr" wrap="square" lIns="274320" rIns="274320" tIns="146304" bIns="146304"/>
           <a:lstStyle/>
           <a:p>
             <a:pPr algn="l">
@@ -3326,11 +3323,10 @@
           </a:fontRef>
         </p:style>
         <p:txBody>
-          <a:bodyPr wrap="square" rtlCol="0" anchor="ctr"/>
+          <a:bodyPr rtlCol="0" anchor="ctr" wrap="square"/>
           <a:lstStyle/>
           <a:p>
             <a:pPr algn="ctr"/>
-            <a:endParaRPr/>
           </a:p>
         </p:txBody>
       </p:sp>
@@ -3351,7 +3347,7 @@
           <a:noFill/>
         </p:spPr>
         <p:txBody>
-          <a:bodyPr wrap="square" lIns="0" tIns="0" rIns="0" bIns="0" anchor="ctr">
+          <a:bodyPr wrap="square" anchor="ctr" lIns="0" rIns="0" tIns="0" bIns="0">
             <a:spAutoFit/>
           </a:bodyPr>
           <a:lstStyle/>
@@ -3418,7 +3414,6 @@
           <a:lstStyle/>
           <a:p>
             <a:pPr algn="ctr"/>
-            <a:endParaRPr/>
           </a:p>
         </p:txBody>
       </p:sp>
@@ -3461,11 +3456,10 @@
           </a:fontRef>
         </p:style>
         <p:txBody>
-          <a:bodyPr wrap="square" rtlCol="0" anchor="ctr"/>
+          <a:bodyPr rtlCol="0" anchor="ctr" wrap="square"/>
           <a:lstStyle/>
           <a:p>
             <a:pPr algn="ctr"/>
-            <a:endParaRPr/>
           </a:p>
         </p:txBody>
       </p:sp>
@@ -3486,7 +3480,7 @@
           <a:noFill/>
         </p:spPr>
         <p:txBody>
-          <a:bodyPr wrap="square" lIns="0" tIns="0" rIns="0" bIns="0" anchor="ctr">
+          <a:bodyPr wrap="square" anchor="ctr" lIns="0" rIns="0" tIns="0" bIns="0">
             <a:spAutoFit/>
           </a:bodyPr>
           <a:lstStyle/>
@@ -3553,7 +3547,6 @@
           <a:lstStyle/>
           <a:p>
             <a:pPr algn="ctr"/>
-            <a:endParaRPr/>
           </a:p>
         </p:txBody>
       </p:sp>
@@ -3596,11 +3589,10 @@
           </a:fontRef>
         </p:style>
         <p:txBody>
-          <a:bodyPr wrap="square" rtlCol="0" anchor="ctr"/>
+          <a:bodyPr rtlCol="0" anchor="ctr" wrap="square"/>
           <a:lstStyle/>
           <a:p>
             <a:pPr algn="ctr"/>
-            <a:endParaRPr/>
           </a:p>
         </p:txBody>
       </p:sp>
@@ -3621,7 +3613,7 @@
           <a:noFill/>
         </p:spPr>
         <p:txBody>
-          <a:bodyPr wrap="square" lIns="0" tIns="0" rIns="0" bIns="0" anchor="ctr">
+          <a:bodyPr wrap="square" anchor="ctr" lIns="0" rIns="0" tIns="0" bIns="0">
             <a:spAutoFit/>
           </a:bodyPr>
           <a:lstStyle/>
@@ -3688,7 +3680,6 @@
           <a:lstStyle/>
           <a:p>
             <a:pPr algn="ctr"/>
-            <a:endParaRPr/>
           </a:p>
         </p:txBody>
       </p:sp>
@@ -3731,11 +3722,10 @@
           </a:fontRef>
         </p:style>
         <p:txBody>
-          <a:bodyPr wrap="square" rtlCol="0" anchor="ctr"/>
+          <a:bodyPr rtlCol="0" anchor="ctr" wrap="square"/>
           <a:lstStyle/>
           <a:p>
             <a:pPr algn="ctr"/>
-            <a:endParaRPr/>
           </a:p>
         </p:txBody>
       </p:sp>
@@ -3756,7 +3746,7 @@
           <a:noFill/>
         </p:spPr>
         <p:txBody>
-          <a:bodyPr wrap="square" lIns="0" tIns="0" rIns="0" bIns="0" anchor="ctr">
+          <a:bodyPr wrap="square" anchor="ctr" lIns="0" rIns="0" tIns="0" bIns="0">
             <a:spAutoFit/>
           </a:bodyPr>
           <a:lstStyle/>
@@ -3799,7 +3789,7 @@
           <a:noFill/>
         </p:spPr>
         <p:txBody>
-          <a:bodyPr wrap="square" lIns="0" tIns="0" rIns="0" bIns="0" anchor="t">
+          <a:bodyPr wrap="square" anchor="t" lIns="0" rIns="0" tIns="0" bIns="0">
             <a:spAutoFit/>
           </a:bodyPr>
           <a:lstStyle/>
@@ -3841,7 +3831,7 @@
           <a:noFill/>
         </p:spPr>
         <p:txBody>
-          <a:bodyPr wrap="square" lIns="0" tIns="0" rIns="0" bIns="0" anchor="t">
+          <a:bodyPr wrap="square" anchor="t" lIns="0" rIns="0" tIns="0" bIns="0">
             <a:spAutoFit/>
           </a:bodyPr>
           <a:lstStyle/>
@@ -3883,7 +3873,7 @@
           <a:noFill/>
         </p:spPr>
         <p:txBody>
-          <a:bodyPr wrap="square" lIns="0" tIns="0" rIns="0" bIns="0" anchor="t">
+          <a:bodyPr wrap="square" anchor="t" lIns="0" rIns="0" tIns="0" bIns="0">
             <a:spAutoFit/>
           </a:bodyPr>
           <a:lstStyle/>
@@ -3917,7 +3907,7 @@
 </file>
 
 <file path=ppt/slides/slide10.xml><?xml version="1.0" encoding="utf-8"?>
-<p:sld xmlns:a="http://schemas.openxmlformats.org/drawingml/2006/main" xmlns:r="http://schemas.openxmlformats.org/officeDocument/2006/relationships" xmlns:p="http://schemas.openxmlformats.org/presentationml/2006/main">
+<p:sld xmlns:a="http://schemas.openxmlformats.org/drawingml/2006/main" xmlns:p="http://schemas.openxmlformats.org/presentationml/2006/main" xmlns:r="http://schemas.openxmlformats.org/officeDocument/2006/relationships">
   <p:cSld>
     <p:spTree>
       <p:nvGrpSpPr>
@@ -3925,14 +3915,7 @@
         <p:cNvGrpSpPr/>
         <p:nvPr/>
       </p:nvGrpSpPr>
-      <p:grpSpPr>
-        <a:xfrm>
-          <a:off x="0" y="0"/>
-          <a:ext cx="0" cy="0"/>
-          <a:chOff x="0" y="0"/>
-          <a:chExt cx="0" cy="0"/>
-        </a:xfrm>
-      </p:grpSpPr>
+      <p:grpSpPr/>
       <p:sp>
         <p:nvSpPr>
           <p:cNvPr id="2" name="TextBox 1"/>
@@ -3950,7 +3933,7 @@
           <a:noFill/>
         </p:spPr>
         <p:txBody>
-          <a:bodyPr wrap="square" lIns="0" tIns="0" rIns="0" bIns="0" anchor="t">
+          <a:bodyPr wrap="square" anchor="t" lIns="0" rIns="0" tIns="0" bIns="0">
             <a:spAutoFit/>
           </a:bodyPr>
           <a:lstStyle/>
@@ -3992,7 +3975,7 @@
           <a:noFill/>
         </p:spPr>
         <p:txBody>
-          <a:bodyPr wrap="square" lIns="0" tIns="0" rIns="0" bIns="0" anchor="t">
+          <a:bodyPr wrap="square" anchor="t" lIns="0" rIns="0" tIns="0" bIns="0">
             <a:spAutoFit/>
           </a:bodyPr>
           <a:lstStyle/>
@@ -4034,7 +4017,7 @@
           <a:noFill/>
         </p:spPr>
         <p:txBody>
-          <a:bodyPr wrap="square" lIns="0" tIns="0" rIns="0" bIns="0" anchor="t">
+          <a:bodyPr wrap="square" anchor="t" lIns="0" rIns="0" tIns="0" bIns="0">
             <a:spAutoFit/>
           </a:bodyPr>
           <a:lstStyle/>
@@ -4096,11 +4079,10 @@
           </a:fontRef>
         </p:style>
         <p:txBody>
-          <a:bodyPr wrap="square" rtlCol="0" anchor="ctr"/>
+          <a:bodyPr rtlCol="0" anchor="ctr" wrap="square"/>
           <a:lstStyle/>
           <a:p>
             <a:pPr algn="ctr"/>
-            <a:endParaRPr/>
           </a:p>
         </p:txBody>
       </p:sp>
@@ -4121,7 +4103,7 @@
           <a:noFill/>
         </p:spPr>
         <p:txBody>
-          <a:bodyPr wrap="square" lIns="0" tIns="0" rIns="0" bIns="0" anchor="t">
+          <a:bodyPr wrap="square" anchor="t" lIns="0" rIns="0" tIns="0" bIns="0">
             <a:spAutoFit/>
           </a:bodyPr>
           <a:lstStyle/>
@@ -4183,11 +4165,10 @@
           </a:fontRef>
         </p:style>
         <p:txBody>
-          <a:bodyPr wrap="square" rtlCol="0" anchor="ctr"/>
+          <a:bodyPr rtlCol="0" anchor="ctr" wrap="square"/>
           <a:lstStyle/>
           <a:p>
             <a:pPr algn="ctr"/>
-            <a:endParaRPr/>
           </a:p>
         </p:txBody>
       </p:sp>
@@ -4208,7 +4189,7 @@
           <a:noFill/>
         </p:spPr>
         <p:txBody>
-          <a:bodyPr wrap="square" lIns="0" tIns="0" rIns="0" bIns="0" anchor="t">
+          <a:bodyPr wrap="square" anchor="t" lIns="0" rIns="0" tIns="0" bIns="0">
             <a:spAutoFit/>
           </a:bodyPr>
           <a:lstStyle/>
@@ -4270,11 +4251,10 @@
           </a:fontRef>
         </p:style>
         <p:txBody>
-          <a:bodyPr wrap="square" rtlCol="0" anchor="ctr"/>
+          <a:bodyPr rtlCol="0" anchor="ctr" wrap="square"/>
           <a:lstStyle/>
           <a:p>
             <a:pPr algn="ctr"/>
-            <a:endParaRPr/>
           </a:p>
         </p:txBody>
       </p:sp>
@@ -4295,7 +4275,7 @@
           <a:noFill/>
         </p:spPr>
         <p:txBody>
-          <a:bodyPr wrap="square" lIns="0" tIns="0" rIns="0" bIns="0" anchor="t">
+          <a:bodyPr wrap="square" anchor="t" lIns="0" rIns="0" tIns="0" bIns="0">
             <a:spAutoFit/>
           </a:bodyPr>
           <a:lstStyle/>
@@ -4357,11 +4337,10 @@
           </a:fontRef>
         </p:style>
         <p:txBody>
-          <a:bodyPr wrap="square" rtlCol="0" anchor="ctr"/>
+          <a:bodyPr rtlCol="0" anchor="ctr" wrap="square"/>
           <a:lstStyle/>
           <a:p>
             <a:pPr algn="ctr"/>
-            <a:endParaRPr/>
           </a:p>
         </p:txBody>
       </p:sp>
@@ -4382,7 +4361,7 @@
           <a:noFill/>
         </p:spPr>
         <p:txBody>
-          <a:bodyPr wrap="square" lIns="0" tIns="0" rIns="0" bIns="0" anchor="t">
+          <a:bodyPr wrap="square" anchor="t" lIns="0" rIns="0" tIns="0" bIns="0">
             <a:spAutoFit/>
           </a:bodyPr>
           <a:lstStyle/>
@@ -4448,7 +4427,7 @@
           </a:fontRef>
         </p:style>
         <p:txBody>
-          <a:bodyPr wrap="square" lIns="292608" rIns="292608" rtlCol="0" anchor="ctr"/>
+          <a:bodyPr rtlCol="0" anchor="ctr" wrap="square" lIns="292608" rIns="292608"/>
           <a:lstStyle/>
           <a:p>
             <a:pPr algn="l">
@@ -4507,7 +4486,7 @@
           <a:noFill/>
         </p:spPr>
         <p:txBody>
-          <a:bodyPr wrap="square" lIns="0" tIns="0" rIns="0" bIns="0" anchor="t">
+          <a:bodyPr wrap="square" anchor="t" lIns="0" rIns="0" tIns="0" bIns="0">
             <a:spAutoFit/>
           </a:bodyPr>
           <a:lstStyle/>
@@ -4520,7 +4499,15 @@
                 <a:spcPts val="0"/>
               </a:spcAft>
             </a:pPr>
-            <a:endParaRPr/>
+            <a:r>
+              <a:rPr sz="900" b="0" i="0">
+                <a:solidFill>
+                  <a:srgbClr val="94A3B8"/>
+                </a:solidFill>
+                <a:latin typeface="Arial"/>
+              </a:rPr>
+              <a:t/>
+            </a:r>
           </a:p>
         </p:txBody>
       </p:sp>
@@ -4541,7 +4528,7 @@
           <a:noFill/>
         </p:spPr>
         <p:txBody>
-          <a:bodyPr wrap="square" lIns="0" tIns="0" rIns="0" bIns="0" anchor="t">
+          <a:bodyPr wrap="square" anchor="t" lIns="0" rIns="0" tIns="0" bIns="0">
             <a:spAutoFit/>
           </a:bodyPr>
           <a:lstStyle/>
@@ -4575,7 +4562,7 @@
 </file>
 
 <file path=ppt/slides/slide11.xml><?xml version="1.0" encoding="utf-8"?>
-<p:sld xmlns:a="http://schemas.openxmlformats.org/drawingml/2006/main" xmlns:r="http://schemas.openxmlformats.org/officeDocument/2006/relationships" xmlns:p="http://schemas.openxmlformats.org/presentationml/2006/main">
+<p:sld xmlns:a="http://schemas.openxmlformats.org/drawingml/2006/main" xmlns:p="http://schemas.openxmlformats.org/presentationml/2006/main" xmlns:r="http://schemas.openxmlformats.org/officeDocument/2006/relationships">
   <p:cSld>
     <p:spTree>
       <p:nvGrpSpPr>
@@ -4583,14 +4570,7 @@
         <p:cNvGrpSpPr/>
         <p:nvPr/>
       </p:nvGrpSpPr>
-      <p:grpSpPr>
-        <a:xfrm>
-          <a:off x="0" y="0"/>
-          <a:ext cx="0" cy="0"/>
-          <a:chOff x="0" y="0"/>
-          <a:chExt cx="0" cy="0"/>
-        </a:xfrm>
-      </p:grpSpPr>
+      <p:grpSpPr/>
       <p:sp>
         <p:nvSpPr>
           <p:cNvPr id="2" name="Rectangle 1"/>
@@ -4628,11 +4608,10 @@
           </a:fontRef>
         </p:style>
         <p:txBody>
-          <a:bodyPr wrap="square" rtlCol="0" anchor="ctr"/>
+          <a:bodyPr rtlCol="0" anchor="ctr" wrap="square"/>
           <a:lstStyle/>
           <a:p>
             <a:pPr algn="ctr"/>
-            <a:endParaRPr/>
           </a:p>
         </p:txBody>
       </p:sp>
@@ -4653,7 +4632,7 @@
           <a:noFill/>
         </p:spPr>
         <p:txBody>
-          <a:bodyPr wrap="square" lIns="0" tIns="0" rIns="0" bIns="0" anchor="t">
+          <a:bodyPr wrap="square" anchor="t" lIns="0" rIns="0" tIns="0" bIns="0">
             <a:spAutoFit/>
           </a:bodyPr>
           <a:lstStyle/>
@@ -4715,11 +4694,10 @@
           </a:fontRef>
         </p:style>
         <p:txBody>
-          <a:bodyPr wrap="square" rtlCol="0" anchor="ctr"/>
+          <a:bodyPr rtlCol="0" anchor="ctr" wrap="square"/>
           <a:lstStyle/>
           <a:p>
             <a:pPr algn="ctr"/>
-            <a:endParaRPr/>
           </a:p>
         </p:txBody>
       </p:sp>
@@ -4732,7 +4710,7 @@
         <p:spPr>
           <a:xfrm>
             <a:off x="1069848" y="1920240"/>
-            <a:ext cx="10344607" cy="277512"/>
+            <a:ext cx="10344607" cy="548640"/>
           </a:xfrm>
           <a:prstGeom prst="rect">
             <a:avLst/>
@@ -4740,7 +4718,7 @@
           <a:noFill/>
         </p:spPr>
         <p:txBody>
-          <a:bodyPr wrap="square" lIns="0" tIns="0" rIns="0" bIns="0" anchor="t">
+          <a:bodyPr wrap="square" anchor="t" lIns="0" rIns="0" tIns="0" bIns="0">
             <a:spAutoFit/>
           </a:bodyPr>
           <a:lstStyle/>
@@ -4754,49 +4732,13 @@
               </a:spcAft>
             </a:pPr>
             <a:r>
-              <a:rPr sz="1600" b="0" i="0" dirty="0">
+              <a:rPr sz="1600" b="0" i="0">
                 <a:solidFill>
                   <a:srgbClr val="1A1A1A"/>
                 </a:solidFill>
                 <a:latin typeface="Arial"/>
               </a:rPr>
-              <a:t>Full pipeline: </a:t>
-            </a:r>
-            <a:r>
-              <a:rPr lang="de-DE" sz="1600" b="0" i="0" dirty="0">
-                <a:solidFill>
-                  <a:srgbClr val="1A1A1A"/>
-                </a:solidFill>
-                <a:latin typeface="Arial"/>
-              </a:rPr>
-              <a:t>5</a:t>
-            </a:r>
-            <a:r>
-              <a:rPr sz="1600" b="0" i="0" dirty="0">
-                <a:solidFill>
-                  <a:srgbClr val="1A1A1A"/>
-                </a:solidFill>
-                <a:latin typeface="Arial"/>
-              </a:rPr>
-              <a:t>_</a:t>
-            </a:r>
-            <a:r>
-              <a:rPr sz="1600" b="0" i="0" dirty="0" err="1">
-                <a:solidFill>
-                  <a:srgbClr val="1A1A1A"/>
-                </a:solidFill>
-                <a:latin typeface="Arial"/>
-              </a:rPr>
-              <a:t>patentreports</a:t>
-            </a:r>
-            <a:r>
-              <a:rPr sz="1600" b="0" i="0" dirty="0">
-                <a:solidFill>
-                  <a:srgbClr val="1A1A1A"/>
-                </a:solidFill>
-                <a:latin typeface="Arial"/>
-              </a:rPr>
-              <a:t>/2_antibiotic_resistance_rebuild/ (notebooks 1–4)</a:t>
+              <a:t>Full pipeline: 6_patentreports/2_antibiotic_resistance_rebuild/ (notebooks 1–4)</a:t>
             </a:r>
           </a:p>
         </p:txBody>
@@ -4838,11 +4780,10 @@
           </a:fontRef>
         </p:style>
         <p:txBody>
-          <a:bodyPr wrap="square" rtlCol="0" anchor="ctr"/>
+          <a:bodyPr rtlCol="0" anchor="ctr" wrap="square"/>
           <a:lstStyle/>
           <a:p>
             <a:pPr algn="ctr"/>
-            <a:endParaRPr/>
           </a:p>
         </p:txBody>
       </p:sp>
@@ -4855,7 +4796,7 @@
         <p:spPr>
           <a:xfrm>
             <a:off x="1069848" y="2578608"/>
-            <a:ext cx="10344607" cy="277512"/>
+            <a:ext cx="10344607" cy="548640"/>
           </a:xfrm>
           <a:prstGeom prst="rect">
             <a:avLst/>
@@ -4863,7 +4804,7 @@
           <a:noFill/>
         </p:spPr>
         <p:txBody>
-          <a:bodyPr wrap="square" lIns="0" tIns="0" rIns="0" bIns="0" anchor="t">
+          <a:bodyPr wrap="square" anchor="t" lIns="0" rIns="0" tIns="0" bIns="0">
             <a:spAutoFit/>
           </a:bodyPr>
           <a:lstStyle/>
@@ -4877,49 +4818,13 @@
               </a:spcAft>
             </a:pPr>
             <a:r>
-              <a:rPr sz="1600" b="0" i="0" dirty="0">
+              <a:rPr sz="1600" b="0" i="0">
                 <a:solidFill>
                   <a:srgbClr val="1A1A1A"/>
                 </a:solidFill>
                 <a:latin typeface="Arial"/>
               </a:rPr>
-              <a:t>Reference report already on file: </a:t>
-            </a:r>
-            <a:r>
-              <a:rPr lang="de-DE" sz="1600" b="0" i="0" dirty="0">
-                <a:solidFill>
-                  <a:srgbClr val="1A1A1A"/>
-                </a:solidFill>
-                <a:latin typeface="Arial"/>
-              </a:rPr>
-              <a:t>5</a:t>
-            </a:r>
-            <a:r>
-              <a:rPr sz="1600" b="0" i="0" dirty="0">
-                <a:solidFill>
-                  <a:srgbClr val="1A1A1A"/>
-                </a:solidFill>
-                <a:latin typeface="Arial"/>
-              </a:rPr>
-              <a:t>_</a:t>
-            </a:r>
-            <a:r>
-              <a:rPr sz="1600" b="0" i="0" dirty="0" err="1">
-                <a:solidFill>
-                  <a:srgbClr val="1A1A1A"/>
-                </a:solidFill>
-                <a:latin typeface="Arial"/>
-              </a:rPr>
-              <a:t>patentreports</a:t>
-            </a:r>
-            <a:r>
-              <a:rPr sz="1600" b="0" i="0" dirty="0">
-                <a:solidFill>
-                  <a:srgbClr val="1A1A1A"/>
-                </a:solidFill>
-                <a:latin typeface="Arial"/>
-              </a:rPr>
-              <a:t>/1_antibiotic_resistance/</a:t>
+              <a:t>Reference report already on file: 6_patentreports/1_antibiotic_resistance/</a:t>
             </a:r>
           </a:p>
         </p:txBody>
@@ -4961,11 +4866,10 @@
           </a:fontRef>
         </p:style>
         <p:txBody>
-          <a:bodyPr wrap="square" rtlCol="0" anchor="ctr"/>
+          <a:bodyPr rtlCol="0" anchor="ctr" wrap="square"/>
           <a:lstStyle/>
           <a:p>
             <a:pPr algn="ctr"/>
-            <a:endParaRPr/>
           </a:p>
         </p:txBody>
       </p:sp>
@@ -4986,7 +4890,7 @@
           <a:noFill/>
         </p:spPr>
         <p:txBody>
-          <a:bodyPr wrap="square" lIns="0" tIns="0" rIns="0" bIns="0" anchor="t">
+          <a:bodyPr wrap="square" anchor="t" lIns="0" rIns="0" tIns="0" bIns="0">
             <a:spAutoFit/>
           </a:bodyPr>
           <a:lstStyle/>
@@ -5050,7 +4954,7 @@
           </a:fontRef>
         </p:style>
         <p:txBody>
-          <a:bodyPr wrap="square" lIns="310896" rIns="310896" rtlCol="0" anchor="ctr"/>
+          <a:bodyPr rtlCol="0" anchor="ctr" wrap="square" lIns="310896" rIns="310896"/>
           <a:lstStyle/>
           <a:p>
             <a:pPr algn="l">
@@ -5128,7 +5032,7 @@
           <a:noFill/>
         </p:spPr>
         <p:txBody>
-          <a:bodyPr wrap="square" lIns="0" tIns="0" rIns="0" bIns="0" anchor="t">
+          <a:bodyPr wrap="square" anchor="t" lIns="0" rIns="0" tIns="0" bIns="0">
             <a:spAutoFit/>
           </a:bodyPr>
           <a:lstStyle/>
@@ -5170,7 +5074,7 @@
           <a:noFill/>
         </p:spPr>
         <p:txBody>
-          <a:bodyPr wrap="square" lIns="0" tIns="0" rIns="0" bIns="0" anchor="t">
+          <a:bodyPr wrap="square" anchor="t" lIns="0" rIns="0" tIns="0" bIns="0">
             <a:spAutoFit/>
           </a:bodyPr>
           <a:lstStyle/>
@@ -5204,7 +5108,7 @@
 </file>
 
 <file path=ppt/slides/slide2.xml><?xml version="1.0" encoding="utf-8"?>
-<p:sld xmlns:a="http://schemas.openxmlformats.org/drawingml/2006/main" xmlns:r="http://schemas.openxmlformats.org/officeDocument/2006/relationships" xmlns:p="http://schemas.openxmlformats.org/presentationml/2006/main">
+<p:sld xmlns:a="http://schemas.openxmlformats.org/drawingml/2006/main" xmlns:p="http://schemas.openxmlformats.org/presentationml/2006/main" xmlns:r="http://schemas.openxmlformats.org/officeDocument/2006/relationships">
   <p:cSld>
     <p:spTree>
       <p:nvGrpSpPr>
@@ -5212,14 +5116,7 @@
         <p:cNvGrpSpPr/>
         <p:nvPr/>
       </p:nvGrpSpPr>
-      <p:grpSpPr>
-        <a:xfrm>
-          <a:off x="0" y="0"/>
-          <a:ext cx="0" cy="0"/>
-          <a:chOff x="0" y="0"/>
-          <a:chExt cx="0" cy="0"/>
-        </a:xfrm>
-      </p:grpSpPr>
+      <p:grpSpPr/>
       <p:sp>
         <p:nvSpPr>
           <p:cNvPr id="2" name="TextBox 1"/>
@@ -5237,7 +5134,7 @@
           <a:noFill/>
         </p:spPr>
         <p:txBody>
-          <a:bodyPr wrap="square" lIns="0" tIns="0" rIns="0" bIns="0" anchor="t">
+          <a:bodyPr wrap="square" anchor="t" lIns="0" rIns="0" tIns="0" bIns="0">
             <a:spAutoFit/>
           </a:bodyPr>
           <a:lstStyle/>
@@ -5279,7 +5176,7 @@
           <a:noFill/>
         </p:spPr>
         <p:txBody>
-          <a:bodyPr wrap="square" lIns="0" tIns="0" rIns="0" bIns="0" anchor="t">
+          <a:bodyPr wrap="square" anchor="t" lIns="0" rIns="0" tIns="0" bIns="0">
             <a:spAutoFit/>
           </a:bodyPr>
           <a:lstStyle/>
@@ -5321,7 +5218,7 @@
           <a:noFill/>
         </p:spPr>
         <p:txBody>
-          <a:bodyPr wrap="square" lIns="0" tIns="0" rIns="0" bIns="0" anchor="t">
+          <a:bodyPr wrap="square" anchor="t" lIns="0" rIns="0" tIns="0" bIns="0">
             <a:spAutoFit/>
           </a:bodyPr>
           <a:lstStyle/>
@@ -5387,7 +5284,7 @@
           </a:fontRef>
         </p:style>
         <p:txBody>
-          <a:bodyPr wrap="square" lIns="274320" tIns="256032" rIns="274320" rtlCol="0" anchor="ctr"/>
+          <a:bodyPr rtlCol="0" anchor="ctr" wrap="square" lIns="274320" rIns="274320" tIns="256032"/>
           <a:lstStyle/>
           <a:p>
             <a:pPr algn="l">
@@ -5489,7 +5386,7 @@
           </a:fontRef>
         </p:style>
         <p:txBody>
-          <a:bodyPr wrap="square" lIns="274320" tIns="256032" rIns="274320" rtlCol="0" anchor="ctr"/>
+          <a:bodyPr rtlCol="0" anchor="ctr" wrap="square" lIns="274320" rIns="274320" tIns="256032"/>
           <a:lstStyle/>
           <a:p>
             <a:pPr algn="l">
@@ -5567,7 +5464,7 @@
           <a:noFill/>
         </p:spPr>
         <p:txBody>
-          <a:bodyPr wrap="square" lIns="0" tIns="0" rIns="0" bIns="0" anchor="t">
+          <a:bodyPr wrap="square" anchor="t" lIns="0" rIns="0" tIns="0" bIns="0">
             <a:spAutoFit/>
           </a:bodyPr>
           <a:lstStyle/>
@@ -5609,7 +5506,7 @@
           <a:noFill/>
         </p:spPr>
         <p:txBody>
-          <a:bodyPr wrap="square" lIns="0" tIns="0" rIns="0" bIns="0" anchor="t">
+          <a:bodyPr wrap="square" anchor="t" lIns="0" rIns="0" tIns="0" bIns="0">
             <a:spAutoFit/>
           </a:bodyPr>
           <a:lstStyle/>
@@ -5622,7 +5519,15 @@
                 <a:spcPts val="0"/>
               </a:spcAft>
             </a:pPr>
-            <a:endParaRPr/>
+            <a:r>
+              <a:rPr sz="900" b="0" i="0">
+                <a:solidFill>
+                  <a:srgbClr val="94A3B8"/>
+                </a:solidFill>
+                <a:latin typeface="Arial"/>
+              </a:rPr>
+              <a:t/>
+            </a:r>
           </a:p>
         </p:txBody>
       </p:sp>
@@ -5643,7 +5548,7 @@
           <a:noFill/>
         </p:spPr>
         <p:txBody>
-          <a:bodyPr wrap="square" lIns="0" tIns="0" rIns="0" bIns="0" anchor="t">
+          <a:bodyPr wrap="square" anchor="t" lIns="0" rIns="0" tIns="0" bIns="0">
             <a:spAutoFit/>
           </a:bodyPr>
           <a:lstStyle/>
@@ -5677,7 +5582,7 @@
 </file>
 
 <file path=ppt/slides/slide3.xml><?xml version="1.0" encoding="utf-8"?>
-<p:sld xmlns:a="http://schemas.openxmlformats.org/drawingml/2006/main" xmlns:r="http://schemas.openxmlformats.org/officeDocument/2006/relationships" xmlns:p="http://schemas.openxmlformats.org/presentationml/2006/main">
+<p:sld xmlns:a="http://schemas.openxmlformats.org/drawingml/2006/main" xmlns:p="http://schemas.openxmlformats.org/presentationml/2006/main" xmlns:r="http://schemas.openxmlformats.org/officeDocument/2006/relationships">
   <p:cSld>
     <p:spTree>
       <p:nvGrpSpPr>
@@ -5685,14 +5590,7 @@
         <p:cNvGrpSpPr/>
         <p:nvPr/>
       </p:nvGrpSpPr>
-      <p:grpSpPr>
-        <a:xfrm>
-          <a:off x="0" y="0"/>
-          <a:ext cx="0" cy="0"/>
-          <a:chOff x="0" y="0"/>
-          <a:chExt cx="0" cy="0"/>
-        </a:xfrm>
-      </p:grpSpPr>
+      <p:grpSpPr/>
       <p:sp>
         <p:nvSpPr>
           <p:cNvPr id="2" name="TextBox 1"/>
@@ -5710,7 +5608,7 @@
           <a:noFill/>
         </p:spPr>
         <p:txBody>
-          <a:bodyPr wrap="square" lIns="0" tIns="0" rIns="0" bIns="0" anchor="t">
+          <a:bodyPr wrap="square" anchor="t" lIns="0" rIns="0" tIns="0" bIns="0">
             <a:spAutoFit/>
           </a:bodyPr>
           <a:lstStyle/>
@@ -5752,7 +5650,7 @@
           <a:noFill/>
         </p:spPr>
         <p:txBody>
-          <a:bodyPr wrap="square" lIns="0" tIns="0" rIns="0" bIns="0" anchor="t">
+          <a:bodyPr wrap="square" anchor="t" lIns="0" rIns="0" tIns="0" bIns="0">
             <a:spAutoFit/>
           </a:bodyPr>
           <a:lstStyle/>
@@ -5794,7 +5692,7 @@
           <a:noFill/>
         </p:spPr>
         <p:txBody>
-          <a:bodyPr wrap="square" lIns="0" tIns="0" rIns="0" bIns="0" anchor="t">
+          <a:bodyPr wrap="square" anchor="t" lIns="0" rIns="0" tIns="0" bIns="0">
             <a:spAutoFit/>
           </a:bodyPr>
           <a:lstStyle/>
@@ -5860,11 +5758,10 @@
           </a:fontRef>
         </p:style>
         <p:txBody>
-          <a:bodyPr wrap="square" rtlCol="0" anchor="ctr"/>
+          <a:bodyPr rtlCol="0" anchor="ctr" wrap="square"/>
           <a:lstStyle/>
           <a:p>
             <a:pPr algn="ctr"/>
-            <a:endParaRPr/>
           </a:p>
         </p:txBody>
       </p:sp>
@@ -5885,7 +5782,7 @@
           <a:noFill/>
         </p:spPr>
         <p:txBody>
-          <a:bodyPr wrap="square" lIns="0" tIns="0" rIns="0" bIns="0" anchor="ctr">
+          <a:bodyPr wrap="square" anchor="ctr" lIns="0" rIns="0" tIns="0" bIns="0">
             <a:spAutoFit/>
           </a:bodyPr>
           <a:lstStyle/>
@@ -5927,7 +5824,7 @@
           <a:noFill/>
         </p:spPr>
         <p:txBody>
-          <a:bodyPr wrap="square" lIns="0" tIns="0" rIns="0" bIns="0" anchor="t">
+          <a:bodyPr wrap="square" anchor="t" lIns="0" rIns="0" tIns="0" bIns="0">
             <a:spAutoFit/>
           </a:bodyPr>
           <a:lstStyle/>
@@ -5969,7 +5866,7 @@
           <a:noFill/>
         </p:spPr>
         <p:txBody>
-          <a:bodyPr wrap="square" lIns="0" tIns="0" rIns="0" bIns="0" anchor="t">
+          <a:bodyPr wrap="square" anchor="t" lIns="0" rIns="0" tIns="0" bIns="0">
             <a:spAutoFit/>
           </a:bodyPr>
           <a:lstStyle/>
@@ -6035,7 +5932,6 @@
           <a:lstStyle/>
           <a:p>
             <a:pPr algn="ctr"/>
-            <a:endParaRPr/>
           </a:p>
         </p:txBody>
       </p:sp>
@@ -6080,11 +5976,10 @@
           </a:fontRef>
         </p:style>
         <p:txBody>
-          <a:bodyPr wrap="square" rtlCol="0" anchor="ctr"/>
+          <a:bodyPr rtlCol="0" anchor="ctr" wrap="square"/>
           <a:lstStyle/>
           <a:p>
             <a:pPr algn="ctr"/>
-            <a:endParaRPr/>
           </a:p>
         </p:txBody>
       </p:sp>
@@ -6105,7 +6000,7 @@
           <a:noFill/>
         </p:spPr>
         <p:txBody>
-          <a:bodyPr wrap="square" lIns="0" tIns="0" rIns="0" bIns="0" anchor="ctr">
+          <a:bodyPr wrap="square" anchor="ctr" lIns="0" rIns="0" tIns="0" bIns="0">
             <a:spAutoFit/>
           </a:bodyPr>
           <a:lstStyle/>
@@ -6147,7 +6042,7 @@
           <a:noFill/>
         </p:spPr>
         <p:txBody>
-          <a:bodyPr wrap="square" lIns="0" tIns="0" rIns="0" bIns="0" anchor="t">
+          <a:bodyPr wrap="square" anchor="t" lIns="0" rIns="0" tIns="0" bIns="0">
             <a:spAutoFit/>
           </a:bodyPr>
           <a:lstStyle/>
@@ -6189,7 +6084,7 @@
           <a:noFill/>
         </p:spPr>
         <p:txBody>
-          <a:bodyPr wrap="square" lIns="0" tIns="0" rIns="0" bIns="0" anchor="t">
+          <a:bodyPr wrap="square" anchor="t" lIns="0" rIns="0" tIns="0" bIns="0">
             <a:spAutoFit/>
           </a:bodyPr>
           <a:lstStyle/>
@@ -6255,7 +6150,6 @@
           <a:lstStyle/>
           <a:p>
             <a:pPr algn="ctr"/>
-            <a:endParaRPr/>
           </a:p>
         </p:txBody>
       </p:sp>
@@ -6300,11 +6194,10 @@
           </a:fontRef>
         </p:style>
         <p:txBody>
-          <a:bodyPr wrap="square" rtlCol="0" anchor="ctr"/>
+          <a:bodyPr rtlCol="0" anchor="ctr" wrap="square"/>
           <a:lstStyle/>
           <a:p>
             <a:pPr algn="ctr"/>
-            <a:endParaRPr/>
           </a:p>
         </p:txBody>
       </p:sp>
@@ -6325,7 +6218,7 @@
           <a:noFill/>
         </p:spPr>
         <p:txBody>
-          <a:bodyPr wrap="square" lIns="0" tIns="0" rIns="0" bIns="0" anchor="ctr">
+          <a:bodyPr wrap="square" anchor="ctr" lIns="0" rIns="0" tIns="0" bIns="0">
             <a:spAutoFit/>
           </a:bodyPr>
           <a:lstStyle/>
@@ -6367,7 +6260,7 @@
           <a:noFill/>
         </p:spPr>
         <p:txBody>
-          <a:bodyPr wrap="square" lIns="0" tIns="0" rIns="0" bIns="0" anchor="t">
+          <a:bodyPr wrap="square" anchor="t" lIns="0" rIns="0" tIns="0" bIns="0">
             <a:spAutoFit/>
           </a:bodyPr>
           <a:lstStyle/>
@@ -6409,7 +6302,7 @@
           <a:noFill/>
         </p:spPr>
         <p:txBody>
-          <a:bodyPr wrap="square" lIns="0" tIns="0" rIns="0" bIns="0" anchor="t">
+          <a:bodyPr wrap="square" anchor="t" lIns="0" rIns="0" tIns="0" bIns="0">
             <a:spAutoFit/>
           </a:bodyPr>
           <a:lstStyle/>
@@ -6475,7 +6368,6 @@
           <a:lstStyle/>
           <a:p>
             <a:pPr algn="ctr"/>
-            <a:endParaRPr/>
           </a:p>
         </p:txBody>
       </p:sp>
@@ -6520,11 +6412,10 @@
           </a:fontRef>
         </p:style>
         <p:txBody>
-          <a:bodyPr wrap="square" rtlCol="0" anchor="ctr"/>
+          <a:bodyPr rtlCol="0" anchor="ctr" wrap="square"/>
           <a:lstStyle/>
           <a:p>
             <a:pPr algn="ctr"/>
-            <a:endParaRPr/>
           </a:p>
         </p:txBody>
       </p:sp>
@@ -6545,7 +6436,7 @@
           <a:noFill/>
         </p:spPr>
         <p:txBody>
-          <a:bodyPr wrap="square" lIns="0" tIns="0" rIns="0" bIns="0" anchor="ctr">
+          <a:bodyPr wrap="square" anchor="ctr" lIns="0" rIns="0" tIns="0" bIns="0">
             <a:spAutoFit/>
           </a:bodyPr>
           <a:lstStyle/>
@@ -6587,7 +6478,7 @@
           <a:noFill/>
         </p:spPr>
         <p:txBody>
-          <a:bodyPr wrap="square" lIns="0" tIns="0" rIns="0" bIns="0" anchor="t">
+          <a:bodyPr wrap="square" anchor="t" lIns="0" rIns="0" tIns="0" bIns="0">
             <a:spAutoFit/>
           </a:bodyPr>
           <a:lstStyle/>
@@ -6629,7 +6520,7 @@
           <a:noFill/>
         </p:spPr>
         <p:txBody>
-          <a:bodyPr wrap="square" lIns="0" tIns="0" rIns="0" bIns="0" anchor="t">
+          <a:bodyPr wrap="square" anchor="t" lIns="0" rIns="0" tIns="0" bIns="0">
             <a:spAutoFit/>
           </a:bodyPr>
           <a:lstStyle/>
@@ -6693,7 +6584,7 @@
           </a:fontRef>
         </p:style>
         <p:txBody>
-          <a:bodyPr wrap="square" lIns="274320" rIns="274320" rtlCol="0" anchor="ctr"/>
+          <a:bodyPr rtlCol="0" anchor="ctr" wrap="square" lIns="274320" rIns="274320"/>
           <a:lstStyle/>
           <a:p>
             <a:pPr algn="l">
@@ -6733,7 +6624,7 @@
           <a:noFill/>
         </p:spPr>
         <p:txBody>
-          <a:bodyPr wrap="square" lIns="0" tIns="0" rIns="0" bIns="0" anchor="t">
+          <a:bodyPr wrap="square" anchor="t" lIns="0" rIns="0" tIns="0" bIns="0">
             <a:spAutoFit/>
           </a:bodyPr>
           <a:lstStyle/>
@@ -6746,7 +6637,15 @@
                 <a:spcPts val="0"/>
               </a:spcAft>
             </a:pPr>
-            <a:endParaRPr/>
+            <a:r>
+              <a:rPr sz="900" b="0" i="0">
+                <a:solidFill>
+                  <a:srgbClr val="94A3B8"/>
+                </a:solidFill>
+                <a:latin typeface="Arial"/>
+              </a:rPr>
+              <a:t/>
+            </a:r>
           </a:p>
         </p:txBody>
       </p:sp>
@@ -6767,7 +6666,7 @@
           <a:noFill/>
         </p:spPr>
         <p:txBody>
-          <a:bodyPr wrap="square" lIns="0" tIns="0" rIns="0" bIns="0" anchor="t">
+          <a:bodyPr wrap="square" anchor="t" lIns="0" rIns="0" tIns="0" bIns="0">
             <a:spAutoFit/>
           </a:bodyPr>
           <a:lstStyle/>
@@ -6801,7 +6700,7 @@
 </file>
 
 <file path=ppt/slides/slide4.xml><?xml version="1.0" encoding="utf-8"?>
-<p:sld xmlns:a="http://schemas.openxmlformats.org/drawingml/2006/main" xmlns:r="http://schemas.openxmlformats.org/officeDocument/2006/relationships" xmlns:p="http://schemas.openxmlformats.org/presentationml/2006/main">
+<p:sld xmlns:a="http://schemas.openxmlformats.org/drawingml/2006/main" xmlns:p="http://schemas.openxmlformats.org/presentationml/2006/main" xmlns:r="http://schemas.openxmlformats.org/officeDocument/2006/relationships">
   <p:cSld>
     <p:spTree>
       <p:nvGrpSpPr>
@@ -6809,14 +6708,7 @@
         <p:cNvGrpSpPr/>
         <p:nvPr/>
       </p:nvGrpSpPr>
-      <p:grpSpPr>
-        <a:xfrm>
-          <a:off x="0" y="0"/>
-          <a:ext cx="0" cy="0"/>
-          <a:chOff x="0" y="0"/>
-          <a:chExt cx="0" cy="0"/>
-        </a:xfrm>
-      </p:grpSpPr>
+      <p:grpSpPr/>
       <p:sp>
         <p:nvSpPr>
           <p:cNvPr id="2" name="TextBox 1"/>
@@ -6834,7 +6726,7 @@
           <a:noFill/>
         </p:spPr>
         <p:txBody>
-          <a:bodyPr wrap="square" lIns="0" tIns="0" rIns="0" bIns="0" anchor="t">
+          <a:bodyPr wrap="square" anchor="t" lIns="0" rIns="0" tIns="0" bIns="0">
             <a:spAutoFit/>
           </a:bodyPr>
           <a:lstStyle/>
@@ -6876,7 +6768,7 @@
           <a:noFill/>
         </p:spPr>
         <p:txBody>
-          <a:bodyPr wrap="square" lIns="0" tIns="0" rIns="0" bIns="0" anchor="t">
+          <a:bodyPr wrap="square" anchor="t" lIns="0" rIns="0" tIns="0" bIns="0">
             <a:spAutoFit/>
           </a:bodyPr>
           <a:lstStyle/>
@@ -6918,7 +6810,7 @@
           <a:noFill/>
         </p:spPr>
         <p:txBody>
-          <a:bodyPr wrap="square" lIns="0" tIns="0" rIns="0" bIns="0" anchor="t">
+          <a:bodyPr wrap="square" anchor="t" lIns="0" rIns="0" tIns="0" bIns="0">
             <a:spAutoFit/>
           </a:bodyPr>
           <a:lstStyle/>
@@ -6984,7 +6876,7 @@
           </a:fontRef>
         </p:style>
         <p:txBody>
-          <a:bodyPr wrap="square" lIns="256032" tIns="182880" rIns="256032" rtlCol="0" anchor="ctr"/>
+          <a:bodyPr rtlCol="0" anchor="ctr" wrap="square" lIns="256032" rIns="256032" tIns="182880"/>
           <a:lstStyle/>
           <a:p>
             <a:pPr algn="l">
@@ -7143,7 +7035,6 @@
           <a:lstStyle/>
           <a:p>
             <a:pPr algn="ctr"/>
-            <a:endParaRPr/>
           </a:p>
         </p:txBody>
       </p:sp>
@@ -7164,7 +7055,7 @@
           <a:noFill/>
         </p:spPr>
         <p:txBody>
-          <a:bodyPr wrap="square" lIns="0" tIns="0" rIns="0" bIns="0" anchor="t">
+          <a:bodyPr wrap="square" anchor="t" lIns="0" rIns="0" tIns="0" bIns="0">
             <a:spAutoFit/>
           </a:bodyPr>
           <a:lstStyle/>
@@ -7230,7 +7121,7 @@
           </a:fontRef>
         </p:style>
         <p:txBody>
-          <a:bodyPr wrap="square" lIns="256032" tIns="182880" rIns="256032" rtlCol="0" anchor="ctr"/>
+          <a:bodyPr rtlCol="0" anchor="ctr" wrap="square" lIns="256032" rIns="256032" tIns="182880"/>
           <a:lstStyle/>
           <a:p>
             <a:pPr algn="l">
@@ -7346,7 +7237,7 @@
           <a:noFill/>
         </p:spPr>
         <p:txBody>
-          <a:bodyPr wrap="square" lIns="0" tIns="0" rIns="0" bIns="0" anchor="t">
+          <a:bodyPr wrap="square" anchor="t" lIns="0" rIns="0" tIns="0" bIns="0">
             <a:spAutoFit/>
           </a:bodyPr>
           <a:lstStyle/>
@@ -7388,7 +7279,7 @@
           <a:noFill/>
         </p:spPr>
         <p:txBody>
-          <a:bodyPr wrap="square" lIns="0" tIns="0" rIns="0" bIns="0" anchor="t">
+          <a:bodyPr wrap="square" anchor="t" lIns="0" rIns="0" tIns="0" bIns="0">
             <a:spAutoFit/>
           </a:bodyPr>
           <a:lstStyle/>
@@ -7422,7 +7313,7 @@
 </file>
 
 <file path=ppt/slides/slide5.xml><?xml version="1.0" encoding="utf-8"?>
-<p:sld xmlns:a="http://schemas.openxmlformats.org/drawingml/2006/main" xmlns:r="http://schemas.openxmlformats.org/officeDocument/2006/relationships" xmlns:p="http://schemas.openxmlformats.org/presentationml/2006/main">
+<p:sld xmlns:a="http://schemas.openxmlformats.org/drawingml/2006/main" xmlns:p="http://schemas.openxmlformats.org/presentationml/2006/main" xmlns:r="http://schemas.openxmlformats.org/officeDocument/2006/relationships">
   <p:cSld>
     <p:spTree>
       <p:nvGrpSpPr>
@@ -7430,14 +7321,7 @@
         <p:cNvGrpSpPr/>
         <p:nvPr/>
       </p:nvGrpSpPr>
-      <p:grpSpPr>
-        <a:xfrm>
-          <a:off x="0" y="0"/>
-          <a:ext cx="0" cy="0"/>
-          <a:chOff x="0" y="0"/>
-          <a:chExt cx="0" cy="0"/>
-        </a:xfrm>
-      </p:grpSpPr>
+      <p:grpSpPr/>
       <p:sp>
         <p:nvSpPr>
           <p:cNvPr id="2" name="TextBox 1"/>
@@ -7455,7 +7339,7 @@
           <a:noFill/>
         </p:spPr>
         <p:txBody>
-          <a:bodyPr wrap="square" lIns="0" tIns="0" rIns="0" bIns="0" anchor="t">
+          <a:bodyPr wrap="square" anchor="t" lIns="0" rIns="0" tIns="0" bIns="0">
             <a:spAutoFit/>
           </a:bodyPr>
           <a:lstStyle/>
@@ -7497,7 +7381,7 @@
           <a:noFill/>
         </p:spPr>
         <p:txBody>
-          <a:bodyPr wrap="square" lIns="0" tIns="0" rIns="0" bIns="0" anchor="t">
+          <a:bodyPr wrap="square" anchor="t" lIns="0" rIns="0" tIns="0" bIns="0">
             <a:spAutoFit/>
           </a:bodyPr>
           <a:lstStyle/>
@@ -7539,7 +7423,7 @@
           <a:noFill/>
         </p:spPr>
         <p:txBody>
-          <a:bodyPr wrap="square" lIns="0" tIns="0" rIns="0" bIns="0" anchor="t">
+          <a:bodyPr wrap="square" anchor="t" lIns="0" rIns="0" tIns="0" bIns="0">
             <a:spAutoFit/>
           </a:bodyPr>
           <a:lstStyle/>
@@ -7605,7 +7489,7 @@
           </a:fontRef>
         </p:style>
         <p:txBody>
-          <a:bodyPr wrap="square" lIns="256032" tIns="182880" rIns="256032" rtlCol="0" anchor="ctr"/>
+          <a:bodyPr rtlCol="0" anchor="ctr" wrap="square" lIns="256032" rIns="256032" tIns="182880"/>
           <a:lstStyle/>
           <a:p>
             <a:pPr algn="l">
@@ -7707,7 +7591,7 @@
           </a:fontRef>
         </p:style>
         <p:txBody>
-          <a:bodyPr wrap="square" lIns="256032" tIns="182880" rIns="256032" rtlCol="0" anchor="ctr"/>
+          <a:bodyPr rtlCol="0" anchor="ctr" wrap="square" lIns="256032" rIns="256032" tIns="182880"/>
           <a:lstStyle/>
           <a:p>
             <a:pPr algn="l">
@@ -7809,7 +7693,7 @@
           </a:fontRef>
         </p:style>
         <p:txBody>
-          <a:bodyPr wrap="square" lIns="292608" rIns="292608" rtlCol="0" anchor="ctr"/>
+          <a:bodyPr rtlCol="0" anchor="ctr" wrap="square" lIns="292608" rIns="292608"/>
           <a:lstStyle/>
           <a:p>
             <a:pPr algn="l">
@@ -7868,7 +7752,7 @@
           <a:noFill/>
         </p:spPr>
         <p:txBody>
-          <a:bodyPr wrap="square" lIns="0" tIns="0" rIns="0" bIns="0" anchor="t">
+          <a:bodyPr wrap="square" anchor="t" lIns="0" rIns="0" tIns="0" bIns="0">
             <a:spAutoFit/>
           </a:bodyPr>
           <a:lstStyle/>
@@ -7881,7 +7765,15 @@
                 <a:spcPts val="0"/>
               </a:spcAft>
             </a:pPr>
-            <a:endParaRPr/>
+            <a:r>
+              <a:rPr sz="900" b="0" i="0">
+                <a:solidFill>
+                  <a:srgbClr val="94A3B8"/>
+                </a:solidFill>
+                <a:latin typeface="Arial"/>
+              </a:rPr>
+              <a:t/>
+            </a:r>
           </a:p>
         </p:txBody>
       </p:sp>
@@ -7902,7 +7794,7 @@
           <a:noFill/>
         </p:spPr>
         <p:txBody>
-          <a:bodyPr wrap="square" lIns="0" tIns="0" rIns="0" bIns="0" anchor="t">
+          <a:bodyPr wrap="square" anchor="t" lIns="0" rIns="0" tIns="0" bIns="0">
             <a:spAutoFit/>
           </a:bodyPr>
           <a:lstStyle/>
@@ -7936,7 +7828,7 @@
 </file>
 
 <file path=ppt/slides/slide6.xml><?xml version="1.0" encoding="utf-8"?>
-<p:sld xmlns:a="http://schemas.openxmlformats.org/drawingml/2006/main" xmlns:r="http://schemas.openxmlformats.org/officeDocument/2006/relationships" xmlns:p="http://schemas.openxmlformats.org/presentationml/2006/main">
+<p:sld xmlns:a="http://schemas.openxmlformats.org/drawingml/2006/main" xmlns:p="http://schemas.openxmlformats.org/presentationml/2006/main" xmlns:r="http://schemas.openxmlformats.org/officeDocument/2006/relationships">
   <p:cSld>
     <p:spTree>
       <p:nvGrpSpPr>
@@ -7944,14 +7836,7 @@
         <p:cNvGrpSpPr/>
         <p:nvPr/>
       </p:nvGrpSpPr>
-      <p:grpSpPr>
-        <a:xfrm>
-          <a:off x="0" y="0"/>
-          <a:ext cx="0" cy="0"/>
-          <a:chOff x="0" y="0"/>
-          <a:chExt cx="0" cy="0"/>
-        </a:xfrm>
-      </p:grpSpPr>
+      <p:grpSpPr/>
       <p:sp>
         <p:nvSpPr>
           <p:cNvPr id="2" name="TextBox 1"/>
@@ -7969,7 +7854,7 @@
           <a:noFill/>
         </p:spPr>
         <p:txBody>
-          <a:bodyPr wrap="square" lIns="0" tIns="0" rIns="0" bIns="0" anchor="t">
+          <a:bodyPr wrap="square" anchor="t" lIns="0" rIns="0" tIns="0" bIns="0">
             <a:spAutoFit/>
           </a:bodyPr>
           <a:lstStyle/>
@@ -8011,7 +7896,7 @@
           <a:noFill/>
         </p:spPr>
         <p:txBody>
-          <a:bodyPr wrap="square" lIns="0" tIns="0" rIns="0" bIns="0" anchor="t">
+          <a:bodyPr wrap="square" anchor="t" lIns="0" rIns="0" tIns="0" bIns="0">
             <a:spAutoFit/>
           </a:bodyPr>
           <a:lstStyle/>
@@ -8053,7 +7938,7 @@
           <a:noFill/>
         </p:spPr>
         <p:txBody>
-          <a:bodyPr wrap="square" lIns="0" tIns="0" rIns="0" bIns="0" anchor="t">
+          <a:bodyPr wrap="square" anchor="t" lIns="0" rIns="0" tIns="0" bIns="0">
             <a:spAutoFit/>
           </a:bodyPr>
           <a:lstStyle/>
@@ -8119,7 +8004,7 @@
           </a:fontRef>
         </p:style>
         <p:txBody>
-          <a:bodyPr wrap="square" lIns="292608" rIns="292608" rtlCol="0" anchor="ctr"/>
+          <a:bodyPr rtlCol="0" anchor="ctr" wrap="square" lIns="292608" rIns="292608"/>
           <a:lstStyle/>
           <a:p>
             <a:pPr algn="l">
@@ -8178,7 +8063,7 @@
           <a:noFill/>
         </p:spPr>
         <p:txBody>
-          <a:bodyPr wrap="square" lIns="0" tIns="0" rIns="0" bIns="0" anchor="t">
+          <a:bodyPr wrap="square" anchor="t" lIns="0" rIns="0" tIns="0" bIns="0">
             <a:spAutoFit/>
           </a:bodyPr>
           <a:lstStyle/>
@@ -8244,7 +8129,7 @@
           </a:fontRef>
         </p:style>
         <p:txBody>
-          <a:bodyPr wrap="square" lIns="256032" tIns="164592" rIns="256032" rtlCol="0" anchor="ctr"/>
+          <a:bodyPr rtlCol="0" anchor="ctr" wrap="square" lIns="256032" rIns="256032" tIns="164592"/>
           <a:lstStyle/>
           <a:p>
             <a:pPr algn="l">
@@ -8327,7 +8212,7 @@
           </a:fontRef>
         </p:style>
         <p:txBody>
-          <a:bodyPr wrap="square" lIns="256032" tIns="164592" rIns="256032" rtlCol="0" anchor="ctr"/>
+          <a:bodyPr rtlCol="0" anchor="ctr" wrap="square" lIns="256032" rIns="256032" tIns="164592"/>
           <a:lstStyle/>
           <a:p>
             <a:pPr algn="l">
@@ -8386,7 +8271,7 @@
           <a:noFill/>
         </p:spPr>
         <p:txBody>
-          <a:bodyPr wrap="square" lIns="0" tIns="0" rIns="0" bIns="0" anchor="t">
+          <a:bodyPr wrap="square" anchor="t" lIns="0" rIns="0" tIns="0" bIns="0">
             <a:spAutoFit/>
           </a:bodyPr>
           <a:lstStyle/>
@@ -8399,7 +8284,15 @@
                 <a:spcPts val="0"/>
               </a:spcAft>
             </a:pPr>
-            <a:endParaRPr/>
+            <a:r>
+              <a:rPr sz="900" b="0" i="0">
+                <a:solidFill>
+                  <a:srgbClr val="94A3B8"/>
+                </a:solidFill>
+                <a:latin typeface="Arial"/>
+              </a:rPr>
+              <a:t/>
+            </a:r>
           </a:p>
         </p:txBody>
       </p:sp>
@@ -8420,7 +8313,7 @@
           <a:noFill/>
         </p:spPr>
         <p:txBody>
-          <a:bodyPr wrap="square" lIns="0" tIns="0" rIns="0" bIns="0" anchor="t">
+          <a:bodyPr wrap="square" anchor="t" lIns="0" rIns="0" tIns="0" bIns="0">
             <a:spAutoFit/>
           </a:bodyPr>
           <a:lstStyle/>
@@ -8454,7 +8347,7 @@
 </file>
 
 <file path=ppt/slides/slide7.xml><?xml version="1.0" encoding="utf-8"?>
-<p:sld xmlns:a="http://schemas.openxmlformats.org/drawingml/2006/main" xmlns:r="http://schemas.openxmlformats.org/officeDocument/2006/relationships" xmlns:p="http://schemas.openxmlformats.org/presentationml/2006/main">
+<p:sld xmlns:a="http://schemas.openxmlformats.org/drawingml/2006/main" xmlns:p="http://schemas.openxmlformats.org/presentationml/2006/main" xmlns:r="http://schemas.openxmlformats.org/officeDocument/2006/relationships">
   <p:cSld>
     <p:spTree>
       <p:nvGrpSpPr>
@@ -8462,14 +8355,7 @@
         <p:cNvGrpSpPr/>
         <p:nvPr/>
       </p:nvGrpSpPr>
-      <p:grpSpPr>
-        <a:xfrm>
-          <a:off x="0" y="0"/>
-          <a:ext cx="0" cy="0"/>
-          <a:chOff x="0" y="0"/>
-          <a:chExt cx="0" cy="0"/>
-        </a:xfrm>
-      </p:grpSpPr>
+      <p:grpSpPr/>
       <p:sp>
         <p:nvSpPr>
           <p:cNvPr id="2" name="TextBox 1"/>
@@ -8487,7 +8373,7 @@
           <a:noFill/>
         </p:spPr>
         <p:txBody>
-          <a:bodyPr wrap="square" lIns="0" tIns="0" rIns="0" bIns="0" anchor="t">
+          <a:bodyPr wrap="square" anchor="t" lIns="0" rIns="0" tIns="0" bIns="0">
             <a:spAutoFit/>
           </a:bodyPr>
           <a:lstStyle/>
@@ -8529,7 +8415,7 @@
           <a:noFill/>
         </p:spPr>
         <p:txBody>
-          <a:bodyPr wrap="square" lIns="0" tIns="0" rIns="0" bIns="0" anchor="t">
+          <a:bodyPr wrap="square" anchor="t" lIns="0" rIns="0" tIns="0" bIns="0">
             <a:spAutoFit/>
           </a:bodyPr>
           <a:lstStyle/>
@@ -8571,7 +8457,7 @@
           <a:noFill/>
         </p:spPr>
         <p:txBody>
-          <a:bodyPr wrap="square" lIns="0" tIns="0" rIns="0" bIns="0" anchor="t">
+          <a:bodyPr wrap="square" anchor="t" lIns="0" rIns="0" tIns="0" bIns="0">
             <a:spAutoFit/>
           </a:bodyPr>
           <a:lstStyle/>
@@ -8633,11 +8519,10 @@
           </a:fontRef>
         </p:style>
         <p:txBody>
-          <a:bodyPr wrap="square" rtlCol="0" anchor="ctr"/>
+          <a:bodyPr rtlCol="0" anchor="ctr" wrap="square"/>
           <a:lstStyle/>
           <a:p>
             <a:pPr algn="ctr"/>
-            <a:endParaRPr/>
           </a:p>
         </p:txBody>
       </p:sp>
@@ -8658,7 +8543,7 @@
           <a:noFill/>
         </p:spPr>
         <p:txBody>
-          <a:bodyPr wrap="square" lIns="0" tIns="0" rIns="0" bIns="0" anchor="ctr">
+          <a:bodyPr wrap="square" anchor="ctr" lIns="0" rIns="0" tIns="0" bIns="0">
             <a:spAutoFit/>
           </a:bodyPr>
           <a:lstStyle/>
@@ -8700,7 +8585,7 @@
           <a:noFill/>
         </p:spPr>
         <p:txBody>
-          <a:bodyPr wrap="square" lIns="0" tIns="0" rIns="0" bIns="0" anchor="t">
+          <a:bodyPr wrap="square" anchor="t" lIns="0" rIns="0" tIns="0" bIns="0">
             <a:spAutoFit/>
           </a:bodyPr>
           <a:lstStyle/>
@@ -8762,11 +8647,10 @@
           </a:fontRef>
         </p:style>
         <p:txBody>
-          <a:bodyPr wrap="square" rtlCol="0" anchor="ctr"/>
+          <a:bodyPr rtlCol="0" anchor="ctr" wrap="square"/>
           <a:lstStyle/>
           <a:p>
             <a:pPr algn="ctr"/>
-            <a:endParaRPr/>
           </a:p>
         </p:txBody>
       </p:sp>
@@ -8787,7 +8671,7 @@
           <a:noFill/>
         </p:spPr>
         <p:txBody>
-          <a:bodyPr wrap="square" lIns="0" tIns="0" rIns="0" bIns="0" anchor="ctr">
+          <a:bodyPr wrap="square" anchor="ctr" lIns="0" rIns="0" tIns="0" bIns="0">
             <a:spAutoFit/>
           </a:bodyPr>
           <a:lstStyle/>
@@ -8829,7 +8713,7 @@
           <a:noFill/>
         </p:spPr>
         <p:txBody>
-          <a:bodyPr wrap="square" lIns="0" tIns="0" rIns="0" bIns="0" anchor="t">
+          <a:bodyPr wrap="square" anchor="t" lIns="0" rIns="0" tIns="0" bIns="0">
             <a:spAutoFit/>
           </a:bodyPr>
           <a:lstStyle/>
@@ -8891,11 +8775,10 @@
           </a:fontRef>
         </p:style>
         <p:txBody>
-          <a:bodyPr wrap="square" rtlCol="0" anchor="ctr"/>
+          <a:bodyPr rtlCol="0" anchor="ctr" wrap="square"/>
           <a:lstStyle/>
           <a:p>
             <a:pPr algn="ctr"/>
-            <a:endParaRPr/>
           </a:p>
         </p:txBody>
       </p:sp>
@@ -8916,7 +8799,7 @@
           <a:noFill/>
         </p:spPr>
         <p:txBody>
-          <a:bodyPr wrap="square" lIns="0" tIns="0" rIns="0" bIns="0" anchor="ctr">
+          <a:bodyPr wrap="square" anchor="ctr" lIns="0" rIns="0" tIns="0" bIns="0">
             <a:spAutoFit/>
           </a:bodyPr>
           <a:lstStyle/>
@@ -8958,7 +8841,7 @@
           <a:noFill/>
         </p:spPr>
         <p:txBody>
-          <a:bodyPr wrap="square" lIns="0" tIns="0" rIns="0" bIns="0" anchor="t">
+          <a:bodyPr wrap="square" anchor="t" lIns="0" rIns="0" tIns="0" bIns="0">
             <a:spAutoFit/>
           </a:bodyPr>
           <a:lstStyle/>
@@ -9020,11 +8903,10 @@
           </a:fontRef>
         </p:style>
         <p:txBody>
-          <a:bodyPr wrap="square" rtlCol="0" anchor="ctr"/>
+          <a:bodyPr rtlCol="0" anchor="ctr" wrap="square"/>
           <a:lstStyle/>
           <a:p>
             <a:pPr algn="ctr"/>
-            <a:endParaRPr/>
           </a:p>
         </p:txBody>
       </p:sp>
@@ -9045,7 +8927,7 @@
           <a:noFill/>
         </p:spPr>
         <p:txBody>
-          <a:bodyPr wrap="square" lIns="0" tIns="0" rIns="0" bIns="0" anchor="ctr">
+          <a:bodyPr wrap="square" anchor="ctr" lIns="0" rIns="0" tIns="0" bIns="0">
             <a:spAutoFit/>
           </a:bodyPr>
           <a:lstStyle/>
@@ -9087,7 +8969,7 @@
           <a:noFill/>
         </p:spPr>
         <p:txBody>
-          <a:bodyPr wrap="square" lIns="0" tIns="0" rIns="0" bIns="0" anchor="t">
+          <a:bodyPr wrap="square" anchor="t" lIns="0" rIns="0" tIns="0" bIns="0">
             <a:spAutoFit/>
           </a:bodyPr>
           <a:lstStyle/>
@@ -9149,11 +9031,10 @@
           </a:fontRef>
         </p:style>
         <p:txBody>
-          <a:bodyPr wrap="square" rtlCol="0" anchor="ctr"/>
+          <a:bodyPr rtlCol="0" anchor="ctr" wrap="square"/>
           <a:lstStyle/>
           <a:p>
             <a:pPr algn="ctr"/>
-            <a:endParaRPr/>
           </a:p>
         </p:txBody>
       </p:sp>
@@ -9174,7 +9055,7 @@
           <a:noFill/>
         </p:spPr>
         <p:txBody>
-          <a:bodyPr wrap="square" lIns="0" tIns="0" rIns="0" bIns="0" anchor="ctr">
+          <a:bodyPr wrap="square" anchor="ctr" lIns="0" rIns="0" tIns="0" bIns="0">
             <a:spAutoFit/>
           </a:bodyPr>
           <a:lstStyle/>
@@ -9216,7 +9097,7 @@
           <a:noFill/>
         </p:spPr>
         <p:txBody>
-          <a:bodyPr wrap="square" lIns="0" tIns="0" rIns="0" bIns="0" anchor="t">
+          <a:bodyPr wrap="square" anchor="t" lIns="0" rIns="0" tIns="0" bIns="0">
             <a:spAutoFit/>
           </a:bodyPr>
           <a:lstStyle/>
@@ -9278,11 +9159,10 @@
           </a:fontRef>
         </p:style>
         <p:txBody>
-          <a:bodyPr wrap="square" rtlCol="0" anchor="ctr"/>
+          <a:bodyPr rtlCol="0" anchor="ctr" wrap="square"/>
           <a:lstStyle/>
           <a:p>
             <a:pPr algn="ctr"/>
-            <a:endParaRPr/>
           </a:p>
         </p:txBody>
       </p:sp>
@@ -9303,7 +9183,7 @@
           <a:noFill/>
         </p:spPr>
         <p:txBody>
-          <a:bodyPr wrap="square" lIns="0" tIns="0" rIns="0" bIns="0" anchor="ctr">
+          <a:bodyPr wrap="square" anchor="ctr" lIns="0" rIns="0" tIns="0" bIns="0">
             <a:spAutoFit/>
           </a:bodyPr>
           <a:lstStyle/>
@@ -9345,7 +9225,7 @@
           <a:noFill/>
         </p:spPr>
         <p:txBody>
-          <a:bodyPr wrap="square" lIns="0" tIns="0" rIns="0" bIns="0" anchor="t">
+          <a:bodyPr wrap="square" anchor="t" lIns="0" rIns="0" tIns="0" bIns="0">
             <a:spAutoFit/>
           </a:bodyPr>
           <a:lstStyle/>
@@ -9407,11 +9287,10 @@
           </a:fontRef>
         </p:style>
         <p:txBody>
-          <a:bodyPr wrap="square" rtlCol="0" anchor="ctr"/>
+          <a:bodyPr rtlCol="0" anchor="ctr" wrap="square"/>
           <a:lstStyle/>
           <a:p>
             <a:pPr algn="ctr"/>
-            <a:endParaRPr/>
           </a:p>
         </p:txBody>
       </p:sp>
@@ -9432,7 +9311,7 @@
           <a:noFill/>
         </p:spPr>
         <p:txBody>
-          <a:bodyPr wrap="square" lIns="0" tIns="0" rIns="0" bIns="0" anchor="ctr">
+          <a:bodyPr wrap="square" anchor="ctr" lIns="0" rIns="0" tIns="0" bIns="0">
             <a:spAutoFit/>
           </a:bodyPr>
           <a:lstStyle/>
@@ -9474,7 +9353,7 @@
           <a:noFill/>
         </p:spPr>
         <p:txBody>
-          <a:bodyPr wrap="square" lIns="0" tIns="0" rIns="0" bIns="0" anchor="t">
+          <a:bodyPr wrap="square" anchor="t" lIns="0" rIns="0" tIns="0" bIns="0">
             <a:spAutoFit/>
           </a:bodyPr>
           <a:lstStyle/>
@@ -9536,11 +9415,10 @@
           </a:fontRef>
         </p:style>
         <p:txBody>
-          <a:bodyPr wrap="square" rtlCol="0" anchor="ctr"/>
+          <a:bodyPr rtlCol="0" anchor="ctr" wrap="square"/>
           <a:lstStyle/>
           <a:p>
             <a:pPr algn="ctr"/>
-            <a:endParaRPr/>
           </a:p>
         </p:txBody>
       </p:sp>
@@ -9561,7 +9439,7 @@
           <a:noFill/>
         </p:spPr>
         <p:txBody>
-          <a:bodyPr wrap="square" lIns="0" tIns="0" rIns="0" bIns="0" anchor="ctr">
+          <a:bodyPr wrap="square" anchor="ctr" lIns="0" rIns="0" tIns="0" bIns="0">
             <a:spAutoFit/>
           </a:bodyPr>
           <a:lstStyle/>
@@ -9603,7 +9481,7 @@
           <a:noFill/>
         </p:spPr>
         <p:txBody>
-          <a:bodyPr wrap="square" lIns="0" tIns="0" rIns="0" bIns="0" anchor="t">
+          <a:bodyPr wrap="square" anchor="t" lIns="0" rIns="0" tIns="0" bIns="0">
             <a:spAutoFit/>
           </a:bodyPr>
           <a:lstStyle/>
@@ -9665,11 +9543,10 @@
           </a:fontRef>
         </p:style>
         <p:txBody>
-          <a:bodyPr wrap="square" rtlCol="0" anchor="ctr"/>
+          <a:bodyPr rtlCol="0" anchor="ctr" wrap="square"/>
           <a:lstStyle/>
           <a:p>
             <a:pPr algn="ctr"/>
-            <a:endParaRPr/>
           </a:p>
         </p:txBody>
       </p:sp>
@@ -9690,7 +9567,7 @@
           <a:noFill/>
         </p:spPr>
         <p:txBody>
-          <a:bodyPr wrap="square" lIns="0" tIns="0" rIns="0" bIns="0" anchor="ctr">
+          <a:bodyPr wrap="square" anchor="ctr" lIns="0" rIns="0" tIns="0" bIns="0">
             <a:spAutoFit/>
           </a:bodyPr>
           <a:lstStyle/>
@@ -9732,7 +9609,7 @@
           <a:noFill/>
         </p:spPr>
         <p:txBody>
-          <a:bodyPr wrap="square" lIns="0" tIns="0" rIns="0" bIns="0" anchor="t">
+          <a:bodyPr wrap="square" anchor="t" lIns="0" rIns="0" tIns="0" bIns="0">
             <a:spAutoFit/>
           </a:bodyPr>
           <a:lstStyle/>
@@ -9794,11 +9671,10 @@
           </a:fontRef>
         </p:style>
         <p:txBody>
-          <a:bodyPr wrap="square" rtlCol="0" anchor="ctr"/>
+          <a:bodyPr rtlCol="0" anchor="ctr" wrap="square"/>
           <a:lstStyle/>
           <a:p>
             <a:pPr algn="ctr"/>
-            <a:endParaRPr/>
           </a:p>
         </p:txBody>
       </p:sp>
@@ -9819,7 +9695,7 @@
           <a:noFill/>
         </p:spPr>
         <p:txBody>
-          <a:bodyPr wrap="square" lIns="0" tIns="0" rIns="0" bIns="0" anchor="ctr">
+          <a:bodyPr wrap="square" anchor="ctr" lIns="0" rIns="0" tIns="0" bIns="0">
             <a:spAutoFit/>
           </a:bodyPr>
           <a:lstStyle/>
@@ -9861,7 +9737,7 @@
           <a:noFill/>
         </p:spPr>
         <p:txBody>
-          <a:bodyPr wrap="square" lIns="0" tIns="0" rIns="0" bIns="0" anchor="t">
+          <a:bodyPr wrap="square" anchor="t" lIns="0" rIns="0" tIns="0" bIns="0">
             <a:spAutoFit/>
           </a:bodyPr>
           <a:lstStyle/>
@@ -9927,7 +9803,7 @@
           </a:fontRef>
         </p:style>
         <p:txBody>
-          <a:bodyPr wrap="square" lIns="274320" rIns="274320" rtlCol="0" anchor="ctr"/>
+          <a:bodyPr rtlCol="0" anchor="ctr" wrap="square" lIns="274320" rIns="274320"/>
           <a:lstStyle/>
           <a:p>
             <a:pPr algn="l">
@@ -9967,7 +9843,7 @@
           <a:noFill/>
         </p:spPr>
         <p:txBody>
-          <a:bodyPr wrap="square" lIns="0" tIns="0" rIns="0" bIns="0" anchor="t">
+          <a:bodyPr wrap="square" anchor="t" lIns="0" rIns="0" tIns="0" bIns="0">
             <a:spAutoFit/>
           </a:bodyPr>
           <a:lstStyle/>
@@ -9980,7 +9856,15 @@
                 <a:spcPts val="0"/>
               </a:spcAft>
             </a:pPr>
-            <a:endParaRPr/>
+            <a:r>
+              <a:rPr sz="900" b="0" i="0">
+                <a:solidFill>
+                  <a:srgbClr val="94A3B8"/>
+                </a:solidFill>
+                <a:latin typeface="Arial"/>
+              </a:rPr>
+              <a:t/>
+            </a:r>
           </a:p>
         </p:txBody>
       </p:sp>
@@ -10001,7 +9885,7 @@
           <a:noFill/>
         </p:spPr>
         <p:txBody>
-          <a:bodyPr wrap="square" lIns="0" tIns="0" rIns="0" bIns="0" anchor="t">
+          <a:bodyPr wrap="square" anchor="t" lIns="0" rIns="0" tIns="0" bIns="0">
             <a:spAutoFit/>
           </a:bodyPr>
           <a:lstStyle/>
@@ -10035,7 +9919,7 @@
 </file>
 
 <file path=ppt/slides/slide8.xml><?xml version="1.0" encoding="utf-8"?>
-<p:sld xmlns:a="http://schemas.openxmlformats.org/drawingml/2006/main" xmlns:r="http://schemas.openxmlformats.org/officeDocument/2006/relationships" xmlns:p="http://schemas.openxmlformats.org/presentationml/2006/main">
+<p:sld xmlns:a="http://schemas.openxmlformats.org/drawingml/2006/main" xmlns:p="http://schemas.openxmlformats.org/presentationml/2006/main" xmlns:r="http://schemas.openxmlformats.org/officeDocument/2006/relationships">
   <p:cSld>
     <p:spTree>
       <p:nvGrpSpPr>
@@ -10043,14 +9927,7 @@
         <p:cNvGrpSpPr/>
         <p:nvPr/>
       </p:nvGrpSpPr>
-      <p:grpSpPr>
-        <a:xfrm>
-          <a:off x="0" y="0"/>
-          <a:ext cx="0" cy="0"/>
-          <a:chOff x="0" y="0"/>
-          <a:chExt cx="0" cy="0"/>
-        </a:xfrm>
-      </p:grpSpPr>
+      <p:grpSpPr/>
       <p:sp>
         <p:nvSpPr>
           <p:cNvPr id="2" name="TextBox 1"/>
@@ -10068,7 +9945,7 @@
           <a:noFill/>
         </p:spPr>
         <p:txBody>
-          <a:bodyPr wrap="square" lIns="0" tIns="0" rIns="0" bIns="0" anchor="t">
+          <a:bodyPr wrap="square" anchor="t" lIns="0" rIns="0" tIns="0" bIns="0">
             <a:spAutoFit/>
           </a:bodyPr>
           <a:lstStyle/>
@@ -10110,7 +9987,7 @@
           <a:noFill/>
         </p:spPr>
         <p:txBody>
-          <a:bodyPr wrap="square" lIns="0" tIns="0" rIns="0" bIns="0" anchor="t">
+          <a:bodyPr wrap="square" anchor="t" lIns="0" rIns="0" tIns="0" bIns="0">
             <a:spAutoFit/>
           </a:bodyPr>
           <a:lstStyle/>
@@ -10152,7 +10029,7 @@
           <a:noFill/>
         </p:spPr>
         <p:txBody>
-          <a:bodyPr wrap="square" lIns="0" tIns="0" rIns="0" bIns="0" anchor="t">
+          <a:bodyPr wrap="square" anchor="t" lIns="0" rIns="0" tIns="0" bIns="0">
             <a:spAutoFit/>
           </a:bodyPr>
           <a:lstStyle/>
@@ -10216,11 +10093,10 @@
           </a:fontRef>
         </p:style>
         <p:txBody>
-          <a:bodyPr wrap="square" rtlCol="0" anchor="ctr"/>
+          <a:bodyPr rtlCol="0" anchor="ctr" wrap="square"/>
           <a:lstStyle/>
           <a:p>
             <a:pPr algn="ctr"/>
-            <a:endParaRPr/>
           </a:p>
         </p:txBody>
       </p:sp>
@@ -10241,7 +10117,7 @@
           <a:noFill/>
         </p:spPr>
         <p:txBody>
-          <a:bodyPr wrap="square" lIns="0" tIns="0" rIns="0" bIns="0" anchor="ctr">
+          <a:bodyPr wrap="square" anchor="ctr" lIns="0" rIns="0" tIns="0" bIns="0">
             <a:spAutoFit/>
           </a:bodyPr>
           <a:lstStyle/>
@@ -10283,7 +10159,7 @@
           <a:noFill/>
         </p:spPr>
         <p:txBody>
-          <a:bodyPr wrap="square" lIns="0" tIns="0" rIns="0" bIns="0" anchor="t">
+          <a:bodyPr wrap="square" anchor="t" lIns="0" rIns="0" tIns="0" bIns="0">
             <a:spAutoFit/>
           </a:bodyPr>
           <a:lstStyle/>
@@ -10366,11 +10242,10 @@
           </a:fontRef>
         </p:style>
         <p:txBody>
-          <a:bodyPr wrap="square" rtlCol="0" anchor="ctr"/>
+          <a:bodyPr rtlCol="0" anchor="ctr" wrap="square"/>
           <a:lstStyle/>
           <a:p>
             <a:pPr algn="ctr"/>
-            <a:endParaRPr/>
           </a:p>
         </p:txBody>
       </p:sp>
@@ -10391,7 +10266,7 @@
           <a:noFill/>
         </p:spPr>
         <p:txBody>
-          <a:bodyPr wrap="square" lIns="0" tIns="0" rIns="0" bIns="0" anchor="ctr">
+          <a:bodyPr wrap="square" anchor="ctr" lIns="0" rIns="0" tIns="0" bIns="0">
             <a:spAutoFit/>
           </a:bodyPr>
           <a:lstStyle/>
@@ -10433,7 +10308,7 @@
           <a:noFill/>
         </p:spPr>
         <p:txBody>
-          <a:bodyPr wrap="square" lIns="0" tIns="0" rIns="0" bIns="0" anchor="t">
+          <a:bodyPr wrap="square" anchor="t" lIns="0" rIns="0" tIns="0" bIns="0">
             <a:spAutoFit/>
           </a:bodyPr>
           <a:lstStyle/>
@@ -10516,11 +10391,10 @@
           </a:fontRef>
         </p:style>
         <p:txBody>
-          <a:bodyPr wrap="square" rtlCol="0" anchor="ctr"/>
+          <a:bodyPr rtlCol="0" anchor="ctr" wrap="square"/>
           <a:lstStyle/>
           <a:p>
             <a:pPr algn="ctr"/>
-            <a:endParaRPr/>
           </a:p>
         </p:txBody>
       </p:sp>
@@ -10541,7 +10415,7 @@
           <a:noFill/>
         </p:spPr>
         <p:txBody>
-          <a:bodyPr wrap="square" lIns="0" tIns="0" rIns="0" bIns="0" anchor="ctr">
+          <a:bodyPr wrap="square" anchor="ctr" lIns="0" rIns="0" tIns="0" bIns="0">
             <a:spAutoFit/>
           </a:bodyPr>
           <a:lstStyle/>
@@ -10583,7 +10457,7 @@
           <a:noFill/>
         </p:spPr>
         <p:txBody>
-          <a:bodyPr wrap="square" lIns="0" tIns="0" rIns="0" bIns="0" anchor="t">
+          <a:bodyPr wrap="square" anchor="t" lIns="0" rIns="0" tIns="0" bIns="0">
             <a:spAutoFit/>
           </a:bodyPr>
           <a:lstStyle/>
@@ -10666,11 +10540,10 @@
           </a:fontRef>
         </p:style>
         <p:txBody>
-          <a:bodyPr wrap="square" rtlCol="0" anchor="ctr"/>
+          <a:bodyPr rtlCol="0" anchor="ctr" wrap="square"/>
           <a:lstStyle/>
           <a:p>
             <a:pPr algn="ctr"/>
-            <a:endParaRPr/>
           </a:p>
         </p:txBody>
       </p:sp>
@@ -10691,7 +10564,7 @@
           <a:noFill/>
         </p:spPr>
         <p:txBody>
-          <a:bodyPr wrap="square" lIns="0" tIns="0" rIns="0" bIns="0" anchor="ctr">
+          <a:bodyPr wrap="square" anchor="ctr" lIns="0" rIns="0" tIns="0" bIns="0">
             <a:spAutoFit/>
           </a:bodyPr>
           <a:lstStyle/>
@@ -10733,7 +10606,7 @@
           <a:noFill/>
         </p:spPr>
         <p:txBody>
-          <a:bodyPr wrap="square" lIns="0" tIns="0" rIns="0" bIns="0" anchor="t">
+          <a:bodyPr wrap="square" anchor="t" lIns="0" rIns="0" tIns="0" bIns="0">
             <a:spAutoFit/>
           </a:bodyPr>
           <a:lstStyle/>
@@ -10818,7 +10691,7 @@
           </a:fontRef>
         </p:style>
         <p:txBody>
-          <a:bodyPr wrap="square" lIns="274320" rIns="274320" rtlCol="0" anchor="ctr"/>
+          <a:bodyPr rtlCol="0" anchor="ctr" wrap="square" lIns="274320" rIns="274320"/>
           <a:lstStyle/>
           <a:p>
             <a:pPr algn="l">
@@ -10858,7 +10731,7 @@
           <a:noFill/>
         </p:spPr>
         <p:txBody>
-          <a:bodyPr wrap="square" lIns="0" tIns="0" rIns="0" bIns="0" anchor="t">
+          <a:bodyPr wrap="square" anchor="t" lIns="0" rIns="0" tIns="0" bIns="0">
             <a:spAutoFit/>
           </a:bodyPr>
           <a:lstStyle/>
@@ -10871,7 +10744,15 @@
                 <a:spcPts val="0"/>
               </a:spcAft>
             </a:pPr>
-            <a:endParaRPr/>
+            <a:r>
+              <a:rPr sz="900" b="0" i="0">
+                <a:solidFill>
+                  <a:srgbClr val="94A3B8"/>
+                </a:solidFill>
+                <a:latin typeface="Arial"/>
+              </a:rPr>
+              <a:t/>
+            </a:r>
           </a:p>
         </p:txBody>
       </p:sp>
@@ -10892,7 +10773,7 @@
           <a:noFill/>
         </p:spPr>
         <p:txBody>
-          <a:bodyPr wrap="square" lIns="0" tIns="0" rIns="0" bIns="0" anchor="t">
+          <a:bodyPr wrap="square" anchor="t" lIns="0" rIns="0" tIns="0" bIns="0">
             <a:spAutoFit/>
           </a:bodyPr>
           <a:lstStyle/>
@@ -10926,7 +10807,7 @@
 </file>
 
 <file path=ppt/slides/slide9.xml><?xml version="1.0" encoding="utf-8"?>
-<p:sld xmlns:a="http://schemas.openxmlformats.org/drawingml/2006/main" xmlns:r="http://schemas.openxmlformats.org/officeDocument/2006/relationships" xmlns:p="http://schemas.openxmlformats.org/presentationml/2006/main">
+<p:sld xmlns:a="http://schemas.openxmlformats.org/drawingml/2006/main" xmlns:p="http://schemas.openxmlformats.org/presentationml/2006/main" xmlns:r="http://schemas.openxmlformats.org/officeDocument/2006/relationships">
   <p:cSld>
     <p:spTree>
       <p:nvGrpSpPr>
@@ -10934,14 +10815,7 @@
         <p:cNvGrpSpPr/>
         <p:nvPr/>
       </p:nvGrpSpPr>
-      <p:grpSpPr>
-        <a:xfrm>
-          <a:off x="0" y="0"/>
-          <a:ext cx="0" cy="0"/>
-          <a:chOff x="0" y="0"/>
-          <a:chExt cx="0" cy="0"/>
-        </a:xfrm>
-      </p:grpSpPr>
+      <p:grpSpPr/>
       <p:sp>
         <p:nvSpPr>
           <p:cNvPr id="2" name="TextBox 1"/>
@@ -10959,7 +10833,7 @@
           <a:noFill/>
         </p:spPr>
         <p:txBody>
-          <a:bodyPr wrap="square" lIns="0" tIns="0" rIns="0" bIns="0" anchor="t">
+          <a:bodyPr wrap="square" anchor="t" lIns="0" rIns="0" tIns="0" bIns="0">
             <a:spAutoFit/>
           </a:bodyPr>
           <a:lstStyle/>
@@ -11001,7 +10875,7 @@
           <a:noFill/>
         </p:spPr>
         <p:txBody>
-          <a:bodyPr wrap="square" lIns="0" tIns="0" rIns="0" bIns="0" anchor="t">
+          <a:bodyPr wrap="square" anchor="t" lIns="0" rIns="0" tIns="0" bIns="0">
             <a:spAutoFit/>
           </a:bodyPr>
           <a:lstStyle/>
@@ -11043,7 +10917,7 @@
           <a:noFill/>
         </p:spPr>
         <p:txBody>
-          <a:bodyPr wrap="square" lIns="0" tIns="0" rIns="0" bIns="0" anchor="t">
+          <a:bodyPr wrap="square" anchor="t" lIns="0" rIns="0" tIns="0" bIns="0">
             <a:spAutoFit/>
           </a:bodyPr>
           <a:lstStyle/>
@@ -11085,7 +10959,7 @@
           <a:noFill/>
         </p:spPr>
         <p:txBody>
-          <a:bodyPr wrap="square" lIns="0" tIns="0" rIns="0" bIns="0" anchor="t">
+          <a:bodyPr wrap="square" anchor="t" lIns="0" rIns="0" tIns="0" bIns="0">
             <a:spAutoFit/>
           </a:bodyPr>
           <a:lstStyle/>
@@ -11151,7 +11025,7 @@
           </a:fontRef>
         </p:style>
         <p:txBody>
-          <a:bodyPr wrap="square" lIns="237744" tIns="182880" rIns="237744" rtlCol="0" anchor="ctr"/>
+          <a:bodyPr rtlCol="0" anchor="ctr" wrap="square" lIns="237744" rIns="237744" tIns="182880"/>
           <a:lstStyle/>
           <a:p>
             <a:pPr algn="l">
@@ -11291,7 +11165,7 @@
           </a:fontRef>
         </p:style>
         <p:txBody>
-          <a:bodyPr wrap="square" lIns="237744" tIns="182880" rIns="237744" rtlCol="0" anchor="ctr"/>
+          <a:bodyPr rtlCol="0" anchor="ctr" wrap="square" lIns="237744" rIns="237744" tIns="182880"/>
           <a:lstStyle/>
           <a:p>
             <a:pPr algn="l">
@@ -11407,7 +11281,7 @@
           <a:noFill/>
         </p:spPr>
         <p:txBody>
-          <a:bodyPr wrap="square" lIns="0" tIns="0" rIns="0" bIns="0" anchor="t">
+          <a:bodyPr wrap="square" anchor="t" lIns="0" rIns="0" tIns="0" bIns="0">
             <a:spAutoFit/>
           </a:bodyPr>
           <a:lstStyle/>
@@ -11420,7 +11294,15 @@
                 <a:spcPts val="0"/>
               </a:spcAft>
             </a:pPr>
-            <a:endParaRPr/>
+            <a:r>
+              <a:rPr sz="900" b="0" i="0">
+                <a:solidFill>
+                  <a:srgbClr val="94A3B8"/>
+                </a:solidFill>
+                <a:latin typeface="Arial"/>
+              </a:rPr>
+              <a:t/>
+            </a:r>
           </a:p>
         </p:txBody>
       </p:sp>
@@ -11441,7 +11323,7 @@
           <a:noFill/>
         </p:spPr>
         <p:txBody>
-          <a:bodyPr wrap="square" lIns="0" tIns="0" rIns="0" bIns="0" anchor="t">
+          <a:bodyPr wrap="square" anchor="t" lIns="0" rIns="0" tIns="0" bIns="0">
             <a:spAutoFit/>
           </a:bodyPr>
           <a:lstStyle/>

</xml_diff>